<commit_message>
v3.0 with Updated Features
</commit_message>
<xml_diff>
--- a/How to Download NVX Dashboard/NVX_Dashboard.pptx
+++ b/How to Download NVX Dashboard/NVX_Dashboard.pptx
@@ -5,15 +5,15 @@
     <p:sldMasterId id="2147483648" r:id="rId1"/>
   </p:sldMasterIdLst>
   <p:sldIdLst>
-    <p:sldId id="256" r:id="rId7"/>
-    <p:sldId id="257" r:id="rId8"/>
-    <p:sldId id="258" r:id="rId9"/>
-    <p:sldId id="259" r:id="rId10"/>
-    <p:sldId id="260" r:id="rId11"/>
-    <p:sldId id="261" r:id="rId12"/>
-    <p:sldId id="262" r:id="rId13"/>
+    <p:sldId id="256" r:id="rId2"/>
+    <p:sldId id="257" r:id="rId3"/>
+    <p:sldId id="258" r:id="rId4"/>
+    <p:sldId id="259" r:id="rId5"/>
+    <p:sldId id="260" r:id="rId6"/>
+    <p:sldId id="261" r:id="rId7"/>
+    <p:sldId id="262" r:id="rId8"/>
   </p:sldIdLst>
-  <p:sldSz cx="12188952" cy="6858000" type="screen4x3"/>
+  <p:sldSz cx="12188825" cy="6858000"/>
   <p:notesSz cx="6858000" cy="9144000"/>
   <p:defaultTextStyle>
     <a:defPPr>
@@ -110,6 +110,22 @@
       </a:defRPr>
     </a:lvl9pPr>
   </p:defaultTextStyle>
+  <p:extLst>
+    <p:ext uri="{EFAFB233-063F-42B5-8137-9DF3F51BA10A}">
+      <p15:sldGuideLst xmlns:p15="http://schemas.microsoft.com/office/powerpoint/2012/main">
+        <p15:guide id="1" orient="horz" pos="2160">
+          <p15:clr>
+            <a:srgbClr val="A4A3A4"/>
+          </p15:clr>
+        </p15:guide>
+        <p15:guide id="2" pos="2880">
+          <p15:clr>
+            <a:srgbClr val="A4A3A4"/>
+          </p15:clr>
+        </p15:guide>
+      </p15:sldGuideLst>
+    </p:ext>
+  </p:extLst>
 </p:presentation>
 </file>
 
@@ -151,10 +167,9 @@
           <a:lstStyle/>
           <a:p>
             <a:r>
-              <a:rPr lang="en-US" smtClean="0"/>
+              <a:rPr lang="en-US"/>
               <a:t>Click to edit Master title style</a:t>
             </a:r>
-            <a:endParaRPr lang="en-US"/>
           </a:p>
         </p:txBody>
       </p:sp>
@@ -270,10 +285,9 @@
           </a:lstStyle>
           <a:p>
             <a:r>
-              <a:rPr lang="en-US" smtClean="0"/>
+              <a:rPr lang="en-US"/>
               <a:t>Click to edit Master subtitle style</a:t>
             </a:r>
-            <a:endParaRPr lang="en-US"/>
           </a:p>
         </p:txBody>
       </p:sp>
@@ -294,7 +308,7 @@
           <a:p>
             <a:fld id="{5BCAD085-E8A6-8845-BD4E-CB4CCA059FC4}" type="datetimeFigureOut">
               <a:rPr lang="en-US" smtClean="0"/>
-              <a:t>1/27/13</a:t>
+              <a:t>3/23/2026</a:t>
             </a:fld>
             <a:endParaRPr lang="en-US"/>
           </a:p>
@@ -388,10 +402,9 @@
           <a:lstStyle/>
           <a:p>
             <a:r>
-              <a:rPr lang="en-US" smtClean="0"/>
+              <a:rPr lang="en-US"/>
               <a:t>Click to edit Master title style</a:t>
             </a:r>
-            <a:endParaRPr lang="en-US"/>
           </a:p>
         </p:txBody>
       </p:sp>
@@ -412,38 +425,37 @@
           <a:p>
             <a:pPr lvl="0"/>
             <a:r>
-              <a:rPr lang="en-US" smtClean="0"/>
+              <a:rPr lang="en-US"/>
               <a:t>Click to edit Master text styles</a:t>
             </a:r>
           </a:p>
           <a:p>
             <a:pPr lvl="1"/>
             <a:r>
-              <a:rPr lang="en-US" smtClean="0"/>
+              <a:rPr lang="en-US"/>
               <a:t>Second level</a:t>
             </a:r>
           </a:p>
           <a:p>
             <a:pPr lvl="2"/>
             <a:r>
-              <a:rPr lang="en-US" smtClean="0"/>
+              <a:rPr lang="en-US"/>
               <a:t>Third level</a:t>
             </a:r>
           </a:p>
           <a:p>
             <a:pPr lvl="3"/>
             <a:r>
-              <a:rPr lang="en-US" smtClean="0"/>
+              <a:rPr lang="en-US"/>
               <a:t>Fourth level</a:t>
             </a:r>
           </a:p>
           <a:p>
             <a:pPr lvl="4"/>
             <a:r>
-              <a:rPr lang="en-US" smtClean="0"/>
+              <a:rPr lang="en-US"/>
               <a:t>Fifth level</a:t>
             </a:r>
-            <a:endParaRPr lang="en-US"/>
           </a:p>
         </p:txBody>
       </p:sp>
@@ -464,7 +476,7 @@
           <a:p>
             <a:fld id="{5BCAD085-E8A6-8845-BD4E-CB4CCA059FC4}" type="datetimeFigureOut">
               <a:rPr lang="en-US" smtClean="0"/>
-              <a:t>1/27/13</a:t>
+              <a:t>3/23/2026</a:t>
             </a:fld>
             <a:endParaRPr lang="en-US"/>
           </a:p>
@@ -563,10 +575,9 @@
           <a:lstStyle/>
           <a:p>
             <a:r>
-              <a:rPr lang="en-US" smtClean="0"/>
+              <a:rPr lang="en-US"/>
               <a:t>Click to edit Master title style</a:t>
             </a:r>
-            <a:endParaRPr lang="en-US"/>
           </a:p>
         </p:txBody>
       </p:sp>
@@ -592,38 +603,37 @@
           <a:p>
             <a:pPr lvl="0"/>
             <a:r>
-              <a:rPr lang="en-US" smtClean="0"/>
+              <a:rPr lang="en-US"/>
               <a:t>Click to edit Master text styles</a:t>
             </a:r>
           </a:p>
           <a:p>
             <a:pPr lvl="1"/>
             <a:r>
-              <a:rPr lang="en-US" smtClean="0"/>
+              <a:rPr lang="en-US"/>
               <a:t>Second level</a:t>
             </a:r>
           </a:p>
           <a:p>
             <a:pPr lvl="2"/>
             <a:r>
-              <a:rPr lang="en-US" smtClean="0"/>
+              <a:rPr lang="en-US"/>
               <a:t>Third level</a:t>
             </a:r>
           </a:p>
           <a:p>
             <a:pPr lvl="3"/>
             <a:r>
-              <a:rPr lang="en-US" smtClean="0"/>
+              <a:rPr lang="en-US"/>
               <a:t>Fourth level</a:t>
             </a:r>
           </a:p>
           <a:p>
             <a:pPr lvl="4"/>
             <a:r>
-              <a:rPr lang="en-US" smtClean="0"/>
+              <a:rPr lang="en-US"/>
               <a:t>Fifth level</a:t>
             </a:r>
-            <a:endParaRPr lang="en-US"/>
           </a:p>
         </p:txBody>
       </p:sp>
@@ -644,7 +654,7 @@
           <a:p>
             <a:fld id="{5BCAD085-E8A6-8845-BD4E-CB4CCA059FC4}" type="datetimeFigureOut">
               <a:rPr lang="en-US" smtClean="0"/>
-              <a:t>1/27/13</a:t>
+              <a:t>3/23/2026</a:t>
             </a:fld>
             <a:endParaRPr lang="en-US"/>
           </a:p>
@@ -738,10 +748,9 @@
           <a:lstStyle/>
           <a:p>
             <a:r>
-              <a:rPr lang="en-US" smtClean="0"/>
+              <a:rPr lang="en-US"/>
               <a:t>Click to edit Master title style</a:t>
             </a:r>
-            <a:endParaRPr lang="en-US"/>
           </a:p>
         </p:txBody>
       </p:sp>
@@ -762,38 +771,37 @@
           <a:p>
             <a:pPr lvl="0"/>
             <a:r>
-              <a:rPr lang="en-US" smtClean="0"/>
+              <a:rPr lang="en-US"/>
               <a:t>Click to edit Master text styles</a:t>
             </a:r>
           </a:p>
           <a:p>
             <a:pPr lvl="1"/>
             <a:r>
-              <a:rPr lang="en-US" smtClean="0"/>
+              <a:rPr lang="en-US"/>
               <a:t>Second level</a:t>
             </a:r>
           </a:p>
           <a:p>
             <a:pPr lvl="2"/>
             <a:r>
-              <a:rPr lang="en-US" smtClean="0"/>
+              <a:rPr lang="en-US"/>
               <a:t>Third level</a:t>
             </a:r>
           </a:p>
           <a:p>
             <a:pPr lvl="3"/>
             <a:r>
-              <a:rPr lang="en-US" smtClean="0"/>
+              <a:rPr lang="en-US"/>
               <a:t>Fourth level</a:t>
             </a:r>
           </a:p>
           <a:p>
             <a:pPr lvl="4"/>
             <a:r>
-              <a:rPr lang="en-US" smtClean="0"/>
+              <a:rPr lang="en-US"/>
               <a:t>Fifth level</a:t>
             </a:r>
-            <a:endParaRPr lang="en-US"/>
           </a:p>
         </p:txBody>
       </p:sp>
@@ -814,7 +822,7 @@
           <a:p>
             <a:fld id="{5BCAD085-E8A6-8845-BD4E-CB4CCA059FC4}" type="datetimeFigureOut">
               <a:rPr lang="en-US" smtClean="0"/>
-              <a:t>1/27/13</a:t>
+              <a:t>3/23/2026</a:t>
             </a:fld>
             <a:endParaRPr lang="en-US"/>
           </a:p>
@@ -917,10 +925,9 @@
           </a:lstStyle>
           <a:p>
             <a:r>
-              <a:rPr lang="en-US" smtClean="0"/>
+              <a:rPr lang="en-US"/>
               <a:t>Click to edit Master title style</a:t>
             </a:r>
-            <a:endParaRPr lang="en-US"/>
           </a:p>
         </p:txBody>
       </p:sp>
@@ -1037,7 +1044,7 @@
           <a:p>
             <a:pPr lvl="0"/>
             <a:r>
-              <a:rPr lang="en-US" smtClean="0"/>
+              <a:rPr lang="en-US"/>
               <a:t>Click to edit Master text styles</a:t>
             </a:r>
           </a:p>
@@ -1060,7 +1067,7 @@
           <a:p>
             <a:fld id="{5BCAD085-E8A6-8845-BD4E-CB4CCA059FC4}" type="datetimeFigureOut">
               <a:rPr lang="en-US" smtClean="0"/>
-              <a:t>1/27/13</a:t>
+              <a:t>3/23/2026</a:t>
             </a:fld>
             <a:endParaRPr lang="en-US"/>
           </a:p>
@@ -1154,10 +1161,9 @@
           <a:lstStyle/>
           <a:p>
             <a:r>
-              <a:rPr lang="en-US" smtClean="0"/>
+              <a:rPr lang="en-US"/>
               <a:t>Click to edit Master title style</a:t>
             </a:r>
-            <a:endParaRPr lang="en-US"/>
           </a:p>
         </p:txBody>
       </p:sp>
@@ -1211,38 +1217,37 @@
           <a:p>
             <a:pPr lvl="0"/>
             <a:r>
-              <a:rPr lang="en-US" smtClean="0"/>
+              <a:rPr lang="en-US"/>
               <a:t>Click to edit Master text styles</a:t>
             </a:r>
           </a:p>
           <a:p>
             <a:pPr lvl="1"/>
             <a:r>
-              <a:rPr lang="en-US" smtClean="0"/>
+              <a:rPr lang="en-US"/>
               <a:t>Second level</a:t>
             </a:r>
           </a:p>
           <a:p>
             <a:pPr lvl="2"/>
             <a:r>
-              <a:rPr lang="en-US" smtClean="0"/>
+              <a:rPr lang="en-US"/>
               <a:t>Third level</a:t>
             </a:r>
           </a:p>
           <a:p>
             <a:pPr lvl="3"/>
             <a:r>
-              <a:rPr lang="en-US" smtClean="0"/>
+              <a:rPr lang="en-US"/>
               <a:t>Fourth level</a:t>
             </a:r>
           </a:p>
           <a:p>
             <a:pPr lvl="4"/>
             <a:r>
-              <a:rPr lang="en-US" smtClean="0"/>
+              <a:rPr lang="en-US"/>
               <a:t>Fifth level</a:t>
             </a:r>
-            <a:endParaRPr lang="en-US"/>
           </a:p>
         </p:txBody>
       </p:sp>
@@ -1296,38 +1301,37 @@
           <a:p>
             <a:pPr lvl="0"/>
             <a:r>
-              <a:rPr lang="en-US" smtClean="0"/>
+              <a:rPr lang="en-US"/>
               <a:t>Click to edit Master text styles</a:t>
             </a:r>
           </a:p>
           <a:p>
             <a:pPr lvl="1"/>
             <a:r>
-              <a:rPr lang="en-US" smtClean="0"/>
+              <a:rPr lang="en-US"/>
               <a:t>Second level</a:t>
             </a:r>
           </a:p>
           <a:p>
             <a:pPr lvl="2"/>
             <a:r>
-              <a:rPr lang="en-US" smtClean="0"/>
+              <a:rPr lang="en-US"/>
               <a:t>Third level</a:t>
             </a:r>
           </a:p>
           <a:p>
             <a:pPr lvl="3"/>
             <a:r>
-              <a:rPr lang="en-US" smtClean="0"/>
+              <a:rPr lang="en-US"/>
               <a:t>Fourth level</a:t>
             </a:r>
           </a:p>
           <a:p>
             <a:pPr lvl="4"/>
             <a:r>
-              <a:rPr lang="en-US" smtClean="0"/>
+              <a:rPr lang="en-US"/>
               <a:t>Fifth level</a:t>
             </a:r>
-            <a:endParaRPr lang="en-US"/>
           </a:p>
         </p:txBody>
       </p:sp>
@@ -1348,7 +1352,7 @@
           <a:p>
             <a:fld id="{5BCAD085-E8A6-8845-BD4E-CB4CCA059FC4}" type="datetimeFigureOut">
               <a:rPr lang="en-US" smtClean="0"/>
-              <a:t>1/27/13</a:t>
+              <a:t>3/23/2026</a:t>
             </a:fld>
             <a:endParaRPr lang="en-US"/>
           </a:p>
@@ -1446,10 +1450,9 @@
           </a:lstStyle>
           <a:p>
             <a:r>
-              <a:rPr lang="en-US" smtClean="0"/>
+              <a:rPr lang="en-US"/>
               <a:t>Click to edit Master title style</a:t>
             </a:r>
-            <a:endParaRPr lang="en-US"/>
           </a:p>
         </p:txBody>
       </p:sp>
@@ -1512,7 +1515,7 @@
           <a:p>
             <a:pPr lvl="0"/>
             <a:r>
-              <a:rPr lang="en-US" smtClean="0"/>
+              <a:rPr lang="en-US"/>
               <a:t>Click to edit Master text styles</a:t>
             </a:r>
           </a:p>
@@ -1568,38 +1571,37 @@
           <a:p>
             <a:pPr lvl="0"/>
             <a:r>
-              <a:rPr lang="en-US" smtClean="0"/>
+              <a:rPr lang="en-US"/>
               <a:t>Click to edit Master text styles</a:t>
             </a:r>
           </a:p>
           <a:p>
             <a:pPr lvl="1"/>
             <a:r>
-              <a:rPr lang="en-US" smtClean="0"/>
+              <a:rPr lang="en-US"/>
               <a:t>Second level</a:t>
             </a:r>
           </a:p>
           <a:p>
             <a:pPr lvl="2"/>
             <a:r>
-              <a:rPr lang="en-US" smtClean="0"/>
+              <a:rPr lang="en-US"/>
               <a:t>Third level</a:t>
             </a:r>
           </a:p>
           <a:p>
             <a:pPr lvl="3"/>
             <a:r>
-              <a:rPr lang="en-US" smtClean="0"/>
+              <a:rPr lang="en-US"/>
               <a:t>Fourth level</a:t>
             </a:r>
           </a:p>
           <a:p>
             <a:pPr lvl="4"/>
             <a:r>
-              <a:rPr lang="en-US" smtClean="0"/>
+              <a:rPr lang="en-US"/>
               <a:t>Fifth level</a:t>
             </a:r>
-            <a:endParaRPr lang="en-US"/>
           </a:p>
         </p:txBody>
       </p:sp>
@@ -1662,7 +1664,7 @@
           <a:p>
             <a:pPr lvl="0"/>
             <a:r>
-              <a:rPr lang="en-US" smtClean="0"/>
+              <a:rPr lang="en-US"/>
               <a:t>Click to edit Master text styles</a:t>
             </a:r>
           </a:p>
@@ -1718,38 +1720,37 @@
           <a:p>
             <a:pPr lvl="0"/>
             <a:r>
-              <a:rPr lang="en-US" smtClean="0"/>
+              <a:rPr lang="en-US"/>
               <a:t>Click to edit Master text styles</a:t>
             </a:r>
           </a:p>
           <a:p>
             <a:pPr lvl="1"/>
             <a:r>
-              <a:rPr lang="en-US" smtClean="0"/>
+              <a:rPr lang="en-US"/>
               <a:t>Second level</a:t>
             </a:r>
           </a:p>
           <a:p>
             <a:pPr lvl="2"/>
             <a:r>
-              <a:rPr lang="en-US" smtClean="0"/>
+              <a:rPr lang="en-US"/>
               <a:t>Third level</a:t>
             </a:r>
           </a:p>
           <a:p>
             <a:pPr lvl="3"/>
             <a:r>
-              <a:rPr lang="en-US" smtClean="0"/>
+              <a:rPr lang="en-US"/>
               <a:t>Fourth level</a:t>
             </a:r>
           </a:p>
           <a:p>
             <a:pPr lvl="4"/>
             <a:r>
-              <a:rPr lang="en-US" smtClean="0"/>
+              <a:rPr lang="en-US"/>
               <a:t>Fifth level</a:t>
             </a:r>
-            <a:endParaRPr lang="en-US"/>
           </a:p>
         </p:txBody>
       </p:sp>
@@ -1770,7 +1771,7 @@
           <a:p>
             <a:fld id="{5BCAD085-E8A6-8845-BD4E-CB4CCA059FC4}" type="datetimeFigureOut">
               <a:rPr lang="en-US" smtClean="0"/>
-              <a:t>1/27/13</a:t>
+              <a:t>3/23/2026</a:t>
             </a:fld>
             <a:endParaRPr lang="en-US"/>
           </a:p>
@@ -1864,10 +1865,9 @@
           <a:lstStyle/>
           <a:p>
             <a:r>
-              <a:rPr lang="en-US" smtClean="0"/>
+              <a:rPr lang="en-US"/>
               <a:t>Click to edit Master title style</a:t>
             </a:r>
-            <a:endParaRPr lang="en-US"/>
           </a:p>
         </p:txBody>
       </p:sp>
@@ -1888,7 +1888,7 @@
           <a:p>
             <a:fld id="{5BCAD085-E8A6-8845-BD4E-CB4CCA059FC4}" type="datetimeFigureOut">
               <a:rPr lang="en-US" smtClean="0"/>
-              <a:t>1/27/13</a:t>
+              <a:t>3/23/2026</a:t>
             </a:fld>
             <a:endParaRPr lang="en-US"/>
           </a:p>
@@ -1983,7 +1983,7 @@
           <a:p>
             <a:fld id="{5BCAD085-E8A6-8845-BD4E-CB4CCA059FC4}" type="datetimeFigureOut">
               <a:rPr lang="en-US" smtClean="0"/>
-              <a:t>1/27/13</a:t>
+              <a:t>3/23/2026</a:t>
             </a:fld>
             <a:endParaRPr lang="en-US"/>
           </a:p>
@@ -2086,10 +2086,9 @@
           </a:lstStyle>
           <a:p>
             <a:r>
-              <a:rPr lang="en-US" smtClean="0"/>
+              <a:rPr lang="en-US"/>
               <a:t>Click to edit Master title style</a:t>
             </a:r>
-            <a:endParaRPr lang="en-US"/>
           </a:p>
         </p:txBody>
       </p:sp>
@@ -2143,38 +2142,37 @@
           <a:p>
             <a:pPr lvl="0"/>
             <a:r>
-              <a:rPr lang="en-US" smtClean="0"/>
+              <a:rPr lang="en-US"/>
               <a:t>Click to edit Master text styles</a:t>
             </a:r>
           </a:p>
           <a:p>
             <a:pPr lvl="1"/>
             <a:r>
-              <a:rPr lang="en-US" smtClean="0"/>
+              <a:rPr lang="en-US"/>
               <a:t>Second level</a:t>
             </a:r>
           </a:p>
           <a:p>
             <a:pPr lvl="2"/>
             <a:r>
-              <a:rPr lang="en-US" smtClean="0"/>
+              <a:rPr lang="en-US"/>
               <a:t>Third level</a:t>
             </a:r>
           </a:p>
           <a:p>
             <a:pPr lvl="3"/>
             <a:r>
-              <a:rPr lang="en-US" smtClean="0"/>
+              <a:rPr lang="en-US"/>
               <a:t>Fourth level</a:t>
             </a:r>
           </a:p>
           <a:p>
             <a:pPr lvl="4"/>
             <a:r>
-              <a:rPr lang="en-US" smtClean="0"/>
+              <a:rPr lang="en-US"/>
               <a:t>Fifth level</a:t>
             </a:r>
-            <a:endParaRPr lang="en-US"/>
           </a:p>
         </p:txBody>
       </p:sp>
@@ -2237,7 +2235,7 @@
           <a:p>
             <a:pPr lvl="0"/>
             <a:r>
-              <a:rPr lang="en-US" smtClean="0"/>
+              <a:rPr lang="en-US"/>
               <a:t>Click to edit Master text styles</a:t>
             </a:r>
           </a:p>
@@ -2260,7 +2258,7 @@
           <a:p>
             <a:fld id="{5BCAD085-E8A6-8845-BD4E-CB4CCA059FC4}" type="datetimeFigureOut">
               <a:rPr lang="en-US" smtClean="0"/>
-              <a:t>1/27/13</a:t>
+              <a:t>3/23/2026</a:t>
             </a:fld>
             <a:endParaRPr lang="en-US"/>
           </a:p>
@@ -2363,10 +2361,9 @@
           </a:lstStyle>
           <a:p>
             <a:r>
-              <a:rPr lang="en-US" smtClean="0"/>
+              <a:rPr lang="en-US"/>
               <a:t>Click to edit Master title style</a:t>
             </a:r>
-            <a:endParaRPr lang="en-US"/>
           </a:p>
         </p:txBody>
       </p:sp>
@@ -2490,7 +2487,7 @@
           <a:p>
             <a:pPr lvl="0"/>
             <a:r>
-              <a:rPr lang="en-US" smtClean="0"/>
+              <a:rPr lang="en-US"/>
               <a:t>Click to edit Master text styles</a:t>
             </a:r>
           </a:p>
@@ -2513,7 +2510,7 @@
           <a:p>
             <a:fld id="{5BCAD085-E8A6-8845-BD4E-CB4CCA059FC4}" type="datetimeFigureOut">
               <a:rPr lang="en-US" smtClean="0"/>
-              <a:t>1/27/13</a:t>
+              <a:t>3/23/2026</a:t>
             </a:fld>
             <a:endParaRPr lang="en-US"/>
           </a:p>
@@ -2622,10 +2619,9 @@
           <a:lstStyle/>
           <a:p>
             <a:r>
-              <a:rPr lang="en-US" smtClean="0"/>
+              <a:rPr lang="en-US"/>
               <a:t>Click to edit Master title style</a:t>
             </a:r>
-            <a:endParaRPr lang="en-US"/>
           </a:p>
         </p:txBody>
       </p:sp>
@@ -2656,38 +2652,37 @@
           <a:p>
             <a:pPr lvl="0"/>
             <a:r>
-              <a:rPr lang="en-US" smtClean="0"/>
+              <a:rPr lang="en-US"/>
               <a:t>Click to edit Master text styles</a:t>
             </a:r>
           </a:p>
           <a:p>
             <a:pPr lvl="1"/>
             <a:r>
-              <a:rPr lang="en-US" smtClean="0"/>
+              <a:rPr lang="en-US"/>
               <a:t>Second level</a:t>
             </a:r>
           </a:p>
           <a:p>
             <a:pPr lvl="2"/>
             <a:r>
-              <a:rPr lang="en-US" smtClean="0"/>
+              <a:rPr lang="en-US"/>
               <a:t>Third level</a:t>
             </a:r>
           </a:p>
           <a:p>
             <a:pPr lvl="3"/>
             <a:r>
-              <a:rPr lang="en-US" smtClean="0"/>
+              <a:rPr lang="en-US"/>
               <a:t>Fourth level</a:t>
             </a:r>
           </a:p>
           <a:p>
             <a:pPr lvl="4"/>
             <a:r>
-              <a:rPr lang="en-US" smtClean="0"/>
+              <a:rPr lang="en-US"/>
               <a:t>Fifth level</a:t>
             </a:r>
-            <a:endParaRPr lang="en-US"/>
           </a:p>
         </p:txBody>
       </p:sp>
@@ -2726,7 +2721,7 @@
           <a:p>
             <a:fld id="{5BCAD085-E8A6-8845-BD4E-CB4CCA059FC4}" type="datetimeFigureOut">
               <a:rPr lang="en-US" smtClean="0"/>
-              <a:t>1/27/13</a:t>
+              <a:t>3/23/2026</a:t>
             </a:fld>
             <a:endParaRPr lang="en-US"/>
           </a:p>
@@ -3085,7 +3080,7 @@
 </file>
 
 <file path=ppt/slides/slide1.xml><?xml version="1.0" encoding="utf-8"?>
-<p:sld xmlns:a="http://schemas.openxmlformats.org/drawingml/2006/main" xmlns:p="http://schemas.openxmlformats.org/presentationml/2006/main" xmlns:r="http://schemas.openxmlformats.org/officeDocument/2006/relationships">
+<p:sld xmlns:a="http://schemas.openxmlformats.org/drawingml/2006/main" xmlns:r="http://schemas.openxmlformats.org/officeDocument/2006/relationships" xmlns:p="http://schemas.openxmlformats.org/presentationml/2006/main">
   <p:cSld>
     <p:spTree>
       <p:nvGrpSpPr>
@@ -3093,7 +3088,14 @@
         <p:cNvGrpSpPr/>
         <p:nvPr/>
       </p:nvGrpSpPr>
-      <p:grpSpPr/>
+      <p:grpSpPr>
+        <a:xfrm>
+          <a:off x="0" y="0"/>
+          <a:ext cx="0" cy="0"/>
+          <a:chOff x="0" y="0"/>
+          <a:chExt cx="0" cy="0"/>
+        </a:xfrm>
+      </p:grpSpPr>
       <p:sp>
         <p:nvSpPr>
           <p:cNvPr id="2" name="Rectangle 1"/>
@@ -3134,6 +3136,7 @@
           <a:lstStyle/>
           <a:p>
             <a:pPr algn="ctr"/>
+            <a:endParaRPr/>
           </a:p>
         </p:txBody>
       </p:sp>
@@ -3177,6 +3180,7 @@
           <a:lstStyle/>
           <a:p>
             <a:pPr algn="ctr"/>
+            <a:endParaRPr/>
           </a:p>
         </p:txBody>
       </p:sp>
@@ -3220,6 +3224,7 @@
           <a:lstStyle/>
           <a:p>
             <a:pPr algn="ctr"/>
+            <a:endParaRPr/>
           </a:p>
         </p:txBody>
       </p:sp>
@@ -3263,6 +3268,7 @@
           <a:lstStyle/>
           <a:p>
             <a:pPr algn="ctr"/>
+            <a:endParaRPr/>
           </a:p>
         </p:txBody>
       </p:sp>
@@ -3306,6 +3312,7 @@
           <a:lstStyle/>
           <a:p>
             <a:pPr algn="ctr"/>
+            <a:endParaRPr/>
           </a:p>
         </p:txBody>
       </p:sp>
@@ -3349,6 +3356,7 @@
           <a:lstStyle/>
           <a:p>
             <a:pPr algn="ctr"/>
+            <a:endParaRPr/>
           </a:p>
         </p:txBody>
       </p:sp>
@@ -3392,6 +3400,7 @@
           <a:lstStyle/>
           <a:p>
             <a:pPr algn="ctr"/>
+            <a:endParaRPr/>
           </a:p>
         </p:txBody>
       </p:sp>
@@ -3435,6 +3444,7 @@
           <a:lstStyle/>
           <a:p>
             <a:pPr algn="ctr"/>
+            <a:endParaRPr/>
           </a:p>
         </p:txBody>
       </p:sp>
@@ -3478,6 +3488,7 @@
           <a:lstStyle/>
           <a:p>
             <a:pPr algn="ctr"/>
+            <a:endParaRPr/>
           </a:p>
         </p:txBody>
       </p:sp>
@@ -3521,6 +3532,7 @@
           <a:lstStyle/>
           <a:p>
             <a:pPr algn="ctr"/>
+            <a:endParaRPr/>
           </a:p>
         </p:txBody>
       </p:sp>
@@ -3564,6 +3576,7 @@
           <a:lstStyle/>
           <a:p>
             <a:pPr algn="ctr"/>
+            <a:endParaRPr/>
           </a:p>
         </p:txBody>
       </p:sp>
@@ -3607,6 +3620,7 @@
           <a:lstStyle/>
           <a:p>
             <a:pPr algn="ctr"/>
+            <a:endParaRPr/>
           </a:p>
         </p:txBody>
       </p:sp>
@@ -3650,6 +3664,7 @@
           <a:lstStyle/>
           <a:p>
             <a:pPr algn="ctr"/>
+            <a:endParaRPr/>
           </a:p>
         </p:txBody>
       </p:sp>
@@ -3693,6 +3708,7 @@
           <a:lstStyle/>
           <a:p>
             <a:pPr algn="ctr"/>
+            <a:endParaRPr/>
           </a:p>
         </p:txBody>
       </p:sp>
@@ -3736,6 +3752,7 @@
           <a:lstStyle/>
           <a:p>
             <a:pPr algn="ctr"/>
+            <a:endParaRPr/>
           </a:p>
         </p:txBody>
       </p:sp>
@@ -3779,6 +3796,7 @@
           <a:lstStyle/>
           <a:p>
             <a:pPr algn="ctr"/>
+            <a:endParaRPr/>
           </a:p>
         </p:txBody>
       </p:sp>
@@ -3822,6 +3840,7 @@
           <a:lstStyle/>
           <a:p>
             <a:pPr algn="ctr"/>
+            <a:endParaRPr/>
           </a:p>
         </p:txBody>
       </p:sp>
@@ -3865,6 +3884,7 @@
           <a:lstStyle/>
           <a:p>
             <a:pPr algn="ctr"/>
+            <a:endParaRPr/>
           </a:p>
         </p:txBody>
       </p:sp>
@@ -3908,6 +3928,7 @@
           <a:lstStyle/>
           <a:p>
             <a:pPr algn="ctr"/>
+            <a:endParaRPr/>
           </a:p>
         </p:txBody>
       </p:sp>
@@ -3951,6 +3972,7 @@
           <a:lstStyle/>
           <a:p>
             <a:pPr algn="ctr"/>
+            <a:endParaRPr/>
           </a:p>
         </p:txBody>
       </p:sp>
@@ -3994,6 +4016,7 @@
           <a:lstStyle/>
           <a:p>
             <a:pPr algn="ctr"/>
+            <a:endParaRPr/>
           </a:p>
         </p:txBody>
       </p:sp>
@@ -4037,6 +4060,7 @@
           <a:lstStyle/>
           <a:p>
             <a:pPr algn="ctr"/>
+            <a:endParaRPr/>
           </a:p>
         </p:txBody>
       </p:sp>
@@ -4080,6 +4104,7 @@
           <a:lstStyle/>
           <a:p>
             <a:pPr algn="ctr"/>
+            <a:endParaRPr/>
           </a:p>
         </p:txBody>
       </p:sp>
@@ -4123,6 +4148,7 @@
           <a:lstStyle/>
           <a:p>
             <a:pPr algn="ctr"/>
+            <a:endParaRPr/>
           </a:p>
         </p:txBody>
       </p:sp>
@@ -4166,6 +4192,7 @@
           <a:lstStyle/>
           <a:p>
             <a:pPr algn="ctr"/>
+            <a:endParaRPr/>
           </a:p>
         </p:txBody>
       </p:sp>
@@ -4209,6 +4236,7 @@
           <a:lstStyle/>
           <a:p>
             <a:pPr algn="ctr"/>
+            <a:endParaRPr/>
           </a:p>
         </p:txBody>
       </p:sp>
@@ -4252,6 +4280,7 @@
           <a:lstStyle/>
           <a:p>
             <a:pPr algn="ctr"/>
+            <a:endParaRPr/>
           </a:p>
         </p:txBody>
       </p:sp>
@@ -4295,6 +4324,7 @@
           <a:lstStyle/>
           <a:p>
             <a:pPr algn="ctr"/>
+            <a:endParaRPr/>
           </a:p>
         </p:txBody>
       </p:sp>
@@ -4338,6 +4368,7 @@
           <a:lstStyle/>
           <a:p>
             <a:pPr algn="ctr"/>
+            <a:endParaRPr/>
           </a:p>
         </p:txBody>
       </p:sp>
@@ -4381,6 +4412,7 @@
           <a:lstStyle/>
           <a:p>
             <a:pPr algn="ctr"/>
+            <a:endParaRPr/>
           </a:p>
         </p:txBody>
       </p:sp>
@@ -4424,6 +4456,7 @@
           <a:lstStyle/>
           <a:p>
             <a:pPr algn="ctr"/>
+            <a:endParaRPr/>
           </a:p>
         </p:txBody>
       </p:sp>
@@ -4467,6 +4500,7 @@
           <a:lstStyle/>
           <a:p>
             <a:pPr algn="ctr"/>
+            <a:endParaRPr/>
           </a:p>
         </p:txBody>
       </p:sp>
@@ -4510,6 +4544,7 @@
           <a:lstStyle/>
           <a:p>
             <a:pPr algn="ctr"/>
+            <a:endParaRPr/>
           </a:p>
         </p:txBody>
       </p:sp>
@@ -4553,6 +4588,7 @@
           <a:lstStyle/>
           <a:p>
             <a:pPr algn="ctr"/>
+            <a:endParaRPr/>
           </a:p>
         </p:txBody>
       </p:sp>
@@ -4596,6 +4632,7 @@
           <a:lstStyle/>
           <a:p>
             <a:pPr algn="ctr"/>
+            <a:endParaRPr/>
           </a:p>
         </p:txBody>
       </p:sp>
@@ -4639,6 +4676,7 @@
           <a:lstStyle/>
           <a:p>
             <a:pPr algn="ctr"/>
+            <a:endParaRPr/>
           </a:p>
         </p:txBody>
       </p:sp>
@@ -4682,6 +4720,7 @@
           <a:lstStyle/>
           <a:p>
             <a:pPr algn="ctr"/>
+            <a:endParaRPr/>
           </a:p>
         </p:txBody>
       </p:sp>
@@ -4725,6 +4764,7 @@
           <a:lstStyle/>
           <a:p>
             <a:pPr algn="ctr"/>
+            <a:endParaRPr/>
           </a:p>
         </p:txBody>
       </p:sp>
@@ -4768,6 +4808,7 @@
           <a:lstStyle/>
           <a:p>
             <a:pPr algn="ctr"/>
+            <a:endParaRPr/>
           </a:p>
         </p:txBody>
       </p:sp>
@@ -4811,6 +4852,7 @@
           <a:lstStyle/>
           <a:p>
             <a:pPr algn="ctr"/>
+            <a:endParaRPr/>
           </a:p>
         </p:txBody>
       </p:sp>
@@ -4854,6 +4896,7 @@
           <a:lstStyle/>
           <a:p>
             <a:pPr algn="ctr"/>
+            <a:endParaRPr/>
           </a:p>
         </p:txBody>
       </p:sp>
@@ -4897,6 +4940,7 @@
           <a:lstStyle/>
           <a:p>
             <a:pPr algn="ctr"/>
+            <a:endParaRPr/>
           </a:p>
         </p:txBody>
       </p:sp>
@@ -4940,6 +4984,7 @@
           <a:lstStyle/>
           <a:p>
             <a:pPr algn="ctr"/>
+            <a:endParaRPr/>
           </a:p>
         </p:txBody>
       </p:sp>
@@ -4983,6 +5028,7 @@
           <a:lstStyle/>
           <a:p>
             <a:pPr algn="ctr"/>
+            <a:endParaRPr/>
           </a:p>
         </p:txBody>
       </p:sp>
@@ -5026,6 +5072,7 @@
           <a:lstStyle/>
           <a:p>
             <a:pPr algn="ctr"/>
+            <a:endParaRPr/>
           </a:p>
         </p:txBody>
       </p:sp>
@@ -5069,6 +5116,7 @@
           <a:lstStyle/>
           <a:p>
             <a:pPr algn="ctr"/>
+            <a:endParaRPr/>
           </a:p>
         </p:txBody>
       </p:sp>
@@ -5112,6 +5160,7 @@
           <a:lstStyle/>
           <a:p>
             <a:pPr algn="ctr"/>
+            <a:endParaRPr/>
           </a:p>
         </p:txBody>
       </p:sp>
@@ -5155,6 +5204,7 @@
           <a:lstStyle/>
           <a:p>
             <a:pPr algn="ctr"/>
+            <a:endParaRPr/>
           </a:p>
         </p:txBody>
       </p:sp>
@@ -5198,6 +5248,7 @@
           <a:lstStyle/>
           <a:p>
             <a:pPr algn="ctr"/>
+            <a:endParaRPr/>
           </a:p>
         </p:txBody>
       </p:sp>
@@ -5241,6 +5292,7 @@
           <a:lstStyle/>
           <a:p>
             <a:pPr algn="ctr"/>
+            <a:endParaRPr/>
           </a:p>
         </p:txBody>
       </p:sp>
@@ -5284,6 +5336,7 @@
           <a:lstStyle/>
           <a:p>
             <a:pPr algn="ctr"/>
+            <a:endParaRPr/>
           </a:p>
         </p:txBody>
       </p:sp>
@@ -5467,6 +5520,7 @@
           <a:lstStyle/>
           <a:p>
             <a:pPr algn="ctr"/>
+            <a:endParaRPr/>
           </a:p>
         </p:txBody>
       </p:sp>
@@ -5580,6 +5634,7 @@
           <a:lstStyle/>
           <a:p>
             <a:pPr algn="ctr"/>
+            <a:endParaRPr/>
           </a:p>
         </p:txBody>
       </p:sp>
@@ -5607,7 +5662,7 @@
           <a:p>
             <a:pPr algn="ctr"/>
             <a:r>
-              <a:rPr sz="900" b="1" i="0">
+              <a:rPr sz="900" b="1" i="0" dirty="0">
                 <a:solidFill>
                   <a:srgbClr val="FFFFFF"/>
                 </a:solidFill>
@@ -5627,7 +5682,7 @@
 </file>
 
 <file path=ppt/slides/slide2.xml><?xml version="1.0" encoding="utf-8"?>
-<p:sld xmlns:a="http://schemas.openxmlformats.org/drawingml/2006/main" xmlns:p="http://schemas.openxmlformats.org/presentationml/2006/main" xmlns:r="http://schemas.openxmlformats.org/officeDocument/2006/relationships">
+<p:sld xmlns:a="http://schemas.openxmlformats.org/drawingml/2006/main" xmlns:r="http://schemas.openxmlformats.org/officeDocument/2006/relationships" xmlns:p="http://schemas.openxmlformats.org/presentationml/2006/main">
   <p:cSld>
     <p:bg>
       <p:bgPr>
@@ -5643,7 +5698,14 @@
         <p:cNvGrpSpPr/>
         <p:nvPr/>
       </p:nvGrpSpPr>
-      <p:grpSpPr/>
+      <p:grpSpPr>
+        <a:xfrm>
+          <a:off x="0" y="0"/>
+          <a:ext cx="0" cy="0"/>
+          <a:chOff x="0" y="0"/>
+          <a:chExt cx="0" cy="0"/>
+        </a:xfrm>
+      </p:grpSpPr>
       <p:sp>
         <p:nvSpPr>
           <p:cNvPr id="2" name="Rectangle 1"/>
@@ -5684,6 +5746,7 @@
           <a:lstStyle/>
           <a:p>
             <a:pPr algn="ctr"/>
+            <a:endParaRPr/>
           </a:p>
         </p:txBody>
       </p:sp>
@@ -5762,6 +5825,7 @@
           <a:lstStyle/>
           <a:p>
             <a:pPr algn="ctr"/>
+            <a:endParaRPr/>
           </a:p>
         </p:txBody>
       </p:sp>
@@ -5843,6 +5907,7 @@
           <a:lstStyle/>
           <a:p>
             <a:pPr algn="ctr"/>
+            <a:endParaRPr/>
           </a:p>
         </p:txBody>
       </p:sp>
@@ -5886,6 +5951,7 @@
           <a:lstStyle/>
           <a:p>
             <a:pPr algn="ctr"/>
+            <a:endParaRPr/>
           </a:p>
         </p:txBody>
       </p:sp>
@@ -6014,6 +6080,7 @@
           <a:lstStyle/>
           <a:p>
             <a:pPr algn="ctr"/>
+            <a:endParaRPr/>
           </a:p>
         </p:txBody>
       </p:sp>
@@ -6057,6 +6124,7 @@
           <a:lstStyle/>
           <a:p>
             <a:pPr algn="ctr"/>
+            <a:endParaRPr/>
           </a:p>
         </p:txBody>
       </p:sp>
@@ -6185,6 +6253,7 @@
           <a:lstStyle/>
           <a:p>
             <a:pPr algn="ctr"/>
+            <a:endParaRPr/>
           </a:p>
         </p:txBody>
       </p:sp>
@@ -6228,6 +6297,7 @@
           <a:lstStyle/>
           <a:p>
             <a:pPr algn="ctr"/>
+            <a:endParaRPr/>
           </a:p>
         </p:txBody>
       </p:sp>
@@ -6275,7 +6345,7 @@
         <p:spPr>
           <a:xfrm>
             <a:off x="8366760" y="2423160"/>
-            <a:ext cx="3291840" cy="822960"/>
+            <a:ext cx="3291840" cy="292388"/>
           </a:xfrm>
           <a:prstGeom prst="rect">
             <a:avLst/>
@@ -6290,25 +6360,31 @@
           <a:p>
             <a:pPr algn="l"/>
             <a:r>
-              <a:rPr sz="1300" b="0">
+              <a:rPr sz="1300" b="0" dirty="0">
                 <a:solidFill>
                   <a:srgbClr val="1E293B"/>
                 </a:solidFill>
                 <a:latin typeface="Calibri"/>
               </a:rPr>
-              <a:t>Works over WiFi or wired.</a:t>
+              <a:t>Works over </a:t>
             </a:r>
-          </a:p>
-          <a:p>
-            <a:pPr algn="l"/>
             <a:r>
-              <a:rPr sz="1300" b="0">
+              <a:rPr sz="1300" b="0" dirty="0" err="1">
                 <a:solidFill>
                   <a:srgbClr val="1E293B"/>
                 </a:solidFill>
                 <a:latin typeface="Calibri"/>
               </a:rPr>
-              <a:t>No complex setup required.</a:t>
+              <a:t>WiFi</a:t>
+            </a:r>
+            <a:r>
+              <a:rPr sz="1300" b="0" dirty="0">
+                <a:solidFill>
+                  <a:srgbClr val="1E293B"/>
+                </a:solidFill>
+                <a:latin typeface="Calibri"/>
+              </a:rPr>
+              <a:t> or wired.</a:t>
             </a:r>
           </a:p>
         </p:txBody>
@@ -6388,6 +6464,7 @@
           <a:lstStyle/>
           <a:p>
             <a:pPr algn="ctr"/>
+            <a:endParaRPr/>
           </a:p>
         </p:txBody>
       </p:sp>
@@ -6466,6 +6543,7 @@
           <a:lstStyle/>
           <a:p>
             <a:pPr algn="ctr"/>
+            <a:endParaRPr/>
           </a:p>
         </p:txBody>
       </p:sp>
@@ -6544,6 +6622,7 @@
           <a:lstStyle/>
           <a:p>
             <a:pPr algn="ctr"/>
+            <a:endParaRPr/>
           </a:p>
         </p:txBody>
       </p:sp>
@@ -6571,7 +6650,7 @@
           <a:p>
             <a:pPr algn="l"/>
             <a:r>
-              <a:rPr sz="1150" b="0" i="0">
+              <a:rPr sz="1150" b="0" i="0" dirty="0">
                 <a:solidFill>
                   <a:srgbClr val="1E293B"/>
                 </a:solidFill>
@@ -6622,6 +6701,7 @@
           <a:lstStyle/>
           <a:p>
             <a:pPr algn="ctr"/>
+            <a:endParaRPr/>
           </a:p>
         </p:txBody>
       </p:sp>
@@ -6649,7 +6729,7 @@
           <a:p>
             <a:pPr algn="l"/>
             <a:r>
-              <a:rPr sz="1150" b="0" i="0">
+              <a:rPr sz="1150" b="0" i="0" dirty="0">
                 <a:solidFill>
                   <a:srgbClr val="1E293B"/>
                 </a:solidFill>
@@ -6700,6 +6780,7 @@
           <a:lstStyle/>
           <a:p>
             <a:pPr algn="ctr"/>
+            <a:endParaRPr/>
           </a:p>
         </p:txBody>
       </p:sp>
@@ -6727,7 +6808,7 @@
           <a:p>
             <a:pPr algn="l"/>
             <a:r>
-              <a:rPr sz="1150" b="0" i="0">
+              <a:rPr sz="1150" b="0" i="0" dirty="0">
                 <a:solidFill>
                   <a:srgbClr val="1E293B"/>
                 </a:solidFill>
@@ -6747,7 +6828,7 @@
 </file>
 
 <file path=ppt/slides/slide3.xml><?xml version="1.0" encoding="utf-8"?>
-<p:sld xmlns:a="http://schemas.openxmlformats.org/drawingml/2006/main" xmlns:p="http://schemas.openxmlformats.org/presentationml/2006/main" xmlns:r="http://schemas.openxmlformats.org/officeDocument/2006/relationships">
+<p:sld xmlns:a="http://schemas.openxmlformats.org/drawingml/2006/main" xmlns:r="http://schemas.openxmlformats.org/officeDocument/2006/relationships" xmlns:p="http://schemas.openxmlformats.org/presentationml/2006/main">
   <p:cSld>
     <p:bg>
       <p:bgPr>
@@ -6763,7 +6844,14 @@
         <p:cNvGrpSpPr/>
         <p:nvPr/>
       </p:nvGrpSpPr>
-      <p:grpSpPr/>
+      <p:grpSpPr>
+        <a:xfrm>
+          <a:off x="0" y="0"/>
+          <a:ext cx="0" cy="0"/>
+          <a:chOff x="0" y="0"/>
+          <a:chExt cx="0" cy="0"/>
+        </a:xfrm>
+      </p:grpSpPr>
       <p:sp>
         <p:nvSpPr>
           <p:cNvPr id="2" name="Rectangle 1"/>
@@ -6804,6 +6892,7 @@
           <a:lstStyle/>
           <a:p>
             <a:pPr algn="ctr"/>
+            <a:endParaRPr/>
           </a:p>
         </p:txBody>
       </p:sp>
@@ -6847,6 +6936,7 @@
           <a:lstStyle/>
           <a:p>
             <a:pPr algn="ctr"/>
+            <a:endParaRPr/>
           </a:p>
         </p:txBody>
       </p:sp>
@@ -6927,6 +7017,7 @@
           <a:lstStyle/>
           <a:p>
             <a:pPr algn="ctr"/>
+            <a:endParaRPr/>
           </a:p>
         </p:txBody>
       </p:sp>
@@ -6970,6 +7061,7 @@
           <a:lstStyle/>
           <a:p>
             <a:pPr algn="ctr"/>
+            <a:endParaRPr/>
           </a:p>
         </p:txBody>
       </p:sp>
@@ -7085,6 +7177,7 @@
           <a:lstStyle/>
           <a:p>
             <a:pPr algn="ctr"/>
+            <a:endParaRPr/>
           </a:p>
         </p:txBody>
       </p:sp>
@@ -7128,6 +7221,7 @@
           <a:lstStyle/>
           <a:p>
             <a:pPr algn="ctr"/>
+            <a:endParaRPr/>
           </a:p>
         </p:txBody>
       </p:sp>
@@ -7243,6 +7337,7 @@
           <a:lstStyle/>
           <a:p>
             <a:pPr algn="ctr"/>
+            <a:endParaRPr/>
           </a:p>
         </p:txBody>
       </p:sp>
@@ -7286,6 +7381,7 @@
           <a:lstStyle/>
           <a:p>
             <a:pPr algn="ctr"/>
+            <a:endParaRPr/>
           </a:p>
         </p:txBody>
       </p:sp>
@@ -7401,6 +7497,7 @@
           <a:lstStyle/>
           <a:p>
             <a:pPr algn="ctr"/>
+            <a:endParaRPr/>
           </a:p>
         </p:txBody>
       </p:sp>
@@ -7444,6 +7541,7 @@
           <a:lstStyle/>
           <a:p>
             <a:pPr algn="ctr"/>
+            <a:endParaRPr/>
           </a:p>
         </p:txBody>
       </p:sp>
@@ -7559,6 +7657,7 @@
           <a:lstStyle/>
           <a:p>
             <a:pPr algn="ctr"/>
+            <a:endParaRPr/>
           </a:p>
         </p:txBody>
       </p:sp>
@@ -7602,6 +7701,7 @@
           <a:lstStyle/>
           <a:p>
             <a:pPr algn="ctr"/>
+            <a:endParaRPr/>
           </a:p>
         </p:txBody>
       </p:sp>
@@ -7717,6 +7817,7 @@
           <a:lstStyle/>
           <a:p>
             <a:pPr algn="ctr"/>
+            <a:endParaRPr/>
           </a:p>
         </p:txBody>
       </p:sp>
@@ -7760,6 +7861,7 @@
           <a:lstStyle/>
           <a:p>
             <a:pPr algn="ctr"/>
+            <a:endParaRPr/>
           </a:p>
         </p:txBody>
       </p:sp>
@@ -7842,7 +7944,7 @@
 </file>
 
 <file path=ppt/slides/slide4.xml><?xml version="1.0" encoding="utf-8"?>
-<p:sld xmlns:a="http://schemas.openxmlformats.org/drawingml/2006/main" xmlns:p="http://schemas.openxmlformats.org/presentationml/2006/main" xmlns:r="http://schemas.openxmlformats.org/officeDocument/2006/relationships">
+<p:sld xmlns:a="http://schemas.openxmlformats.org/drawingml/2006/main" xmlns:r="http://schemas.openxmlformats.org/officeDocument/2006/relationships" xmlns:p="http://schemas.openxmlformats.org/presentationml/2006/main">
   <p:cSld>
     <p:bg>
       <p:bgPr>
@@ -7858,7 +7960,14 @@
         <p:cNvGrpSpPr/>
         <p:nvPr/>
       </p:nvGrpSpPr>
-      <p:grpSpPr/>
+      <p:grpSpPr>
+        <a:xfrm>
+          <a:off x="0" y="0"/>
+          <a:ext cx="0" cy="0"/>
+          <a:chOff x="0" y="0"/>
+          <a:chExt cx="0" cy="0"/>
+        </a:xfrm>
+      </p:grpSpPr>
       <p:sp>
         <p:nvSpPr>
           <p:cNvPr id="2" name="Rectangle 1"/>
@@ -7899,6 +8008,7 @@
           <a:lstStyle/>
           <a:p>
             <a:pPr algn="ctr"/>
+            <a:endParaRPr/>
           </a:p>
         </p:txBody>
       </p:sp>
@@ -7942,6 +8052,7 @@
           <a:lstStyle/>
           <a:p>
             <a:pPr algn="ctr"/>
+            <a:endParaRPr/>
           </a:p>
         </p:txBody>
       </p:sp>
@@ -8022,6 +8133,7 @@
           <a:lstStyle/>
           <a:p>
             <a:pPr algn="ctr"/>
+            <a:endParaRPr/>
           </a:p>
         </p:txBody>
       </p:sp>
@@ -8065,6 +8177,7 @@
           <a:lstStyle/>
           <a:p>
             <a:pPr algn="ctr"/>
+            <a:endParaRPr/>
           </a:p>
         </p:txBody>
       </p:sp>
@@ -8178,6 +8291,7 @@
           <a:lstStyle/>
           <a:p>
             <a:pPr algn="ctr"/>
+            <a:endParaRPr/>
           </a:p>
         </p:txBody>
       </p:sp>
@@ -8293,6 +8407,7 @@
           <a:lstStyle/>
           <a:p>
             <a:pPr algn="ctr"/>
+            <a:endParaRPr/>
           </a:p>
         </p:txBody>
       </p:sp>
@@ -8336,6 +8451,7 @@
           <a:lstStyle/>
           <a:p>
             <a:pPr algn="ctr"/>
+            <a:endParaRPr/>
           </a:p>
         </p:txBody>
       </p:sp>
@@ -8449,6 +8565,7 @@
           <a:lstStyle/>
           <a:p>
             <a:pPr algn="ctr"/>
+            <a:endParaRPr/>
           </a:p>
         </p:txBody>
       </p:sp>
@@ -8529,6 +8646,7 @@
           <a:lstStyle/>
           <a:p>
             <a:pPr algn="ctr"/>
+            <a:endParaRPr/>
           </a:p>
         </p:txBody>
       </p:sp>
@@ -8572,6 +8690,7 @@
           <a:lstStyle/>
           <a:p>
             <a:pPr algn="ctr"/>
+            <a:endParaRPr/>
           </a:p>
         </p:txBody>
       </p:sp>
@@ -8685,6 +8804,7 @@
           <a:lstStyle/>
           <a:p>
             <a:pPr algn="ctr"/>
+            <a:endParaRPr/>
           </a:p>
         </p:txBody>
       </p:sp>
@@ -8800,6 +8920,7 @@
           <a:lstStyle/>
           <a:p>
             <a:pPr algn="ctr"/>
+            <a:endParaRPr/>
           </a:p>
         </p:txBody>
       </p:sp>
@@ -8843,6 +8964,7 @@
           <a:lstStyle/>
           <a:p>
             <a:pPr algn="ctr"/>
+            <a:endParaRPr/>
           </a:p>
         </p:txBody>
       </p:sp>
@@ -8956,6 +9078,7 @@
           <a:lstStyle/>
           <a:p>
             <a:pPr algn="ctr"/>
+            <a:endParaRPr/>
           </a:p>
         </p:txBody>
       </p:sp>
@@ -9038,7 +9161,7 @@
 </file>
 
 <file path=ppt/slides/slide5.xml><?xml version="1.0" encoding="utf-8"?>
-<p:sld xmlns:a="http://schemas.openxmlformats.org/drawingml/2006/main" xmlns:p="http://schemas.openxmlformats.org/presentationml/2006/main" xmlns:r="http://schemas.openxmlformats.org/officeDocument/2006/relationships">
+<p:sld xmlns:a="http://schemas.openxmlformats.org/drawingml/2006/main" xmlns:r="http://schemas.openxmlformats.org/officeDocument/2006/relationships" xmlns:p="http://schemas.openxmlformats.org/presentationml/2006/main">
   <p:cSld>
     <p:bg>
       <p:bgPr>
@@ -9054,7 +9177,14 @@
         <p:cNvGrpSpPr/>
         <p:nvPr/>
       </p:nvGrpSpPr>
-      <p:grpSpPr/>
+      <p:grpSpPr>
+        <a:xfrm>
+          <a:off x="0" y="0"/>
+          <a:ext cx="0" cy="0"/>
+          <a:chOff x="0" y="0"/>
+          <a:chExt cx="0" cy="0"/>
+        </a:xfrm>
+      </p:grpSpPr>
       <p:sp>
         <p:nvSpPr>
           <p:cNvPr id="2" name="Rectangle 1"/>
@@ -9095,6 +9225,7 @@
           <a:lstStyle/>
           <a:p>
             <a:pPr algn="ctr"/>
+            <a:endParaRPr/>
           </a:p>
         </p:txBody>
       </p:sp>
@@ -9138,6 +9269,7 @@
           <a:lstStyle/>
           <a:p>
             <a:pPr algn="ctr"/>
+            <a:endParaRPr/>
           </a:p>
         </p:txBody>
       </p:sp>
@@ -9251,6 +9383,7 @@
           <a:lstStyle/>
           <a:p>
             <a:pPr algn="ctr"/>
+            <a:endParaRPr/>
           </a:p>
         </p:txBody>
       </p:sp>
@@ -9749,6 +9882,7 @@
           <a:lstStyle/>
           <a:p>
             <a:pPr algn="ctr"/>
+            <a:endParaRPr/>
           </a:p>
         </p:txBody>
       </p:sp>
@@ -9792,6 +9926,7 @@
           <a:lstStyle/>
           <a:p>
             <a:pPr algn="ctr"/>
+            <a:endParaRPr/>
           </a:p>
         </p:txBody>
       </p:sp>
@@ -9905,6 +10040,7 @@
           <a:lstStyle/>
           <a:p>
             <a:pPr algn="ctr"/>
+            <a:endParaRPr/>
           </a:p>
         </p:txBody>
       </p:sp>
@@ -10018,6 +10154,7 @@
           <a:lstStyle/>
           <a:p>
             <a:pPr algn="ctr"/>
+            <a:endParaRPr/>
           </a:p>
         </p:txBody>
       </p:sp>
@@ -10131,6 +10268,7 @@
           <a:lstStyle/>
           <a:p>
             <a:pPr algn="ctr"/>
+            <a:endParaRPr/>
           </a:p>
         </p:txBody>
       </p:sp>
@@ -10244,6 +10382,7 @@
           <a:lstStyle/>
           <a:p>
             <a:pPr algn="ctr"/>
+            <a:endParaRPr/>
           </a:p>
         </p:txBody>
       </p:sp>
@@ -10357,6 +10496,7 @@
           <a:lstStyle/>
           <a:p>
             <a:pPr algn="ctr"/>
+            <a:endParaRPr/>
           </a:p>
         </p:txBody>
       </p:sp>
@@ -10470,6 +10610,7 @@
           <a:lstStyle/>
           <a:p>
             <a:pPr algn="ctr"/>
+            <a:endParaRPr/>
           </a:p>
         </p:txBody>
       </p:sp>
@@ -10583,6 +10724,7 @@
           <a:lstStyle/>
           <a:p>
             <a:pPr algn="ctr"/>
+            <a:endParaRPr/>
           </a:p>
         </p:txBody>
       </p:sp>
@@ -10665,7 +10807,7 @@
 </file>
 
 <file path=ppt/slides/slide6.xml><?xml version="1.0" encoding="utf-8"?>
-<p:sld xmlns:a="http://schemas.openxmlformats.org/drawingml/2006/main" xmlns:p="http://schemas.openxmlformats.org/presentationml/2006/main" xmlns:r="http://schemas.openxmlformats.org/officeDocument/2006/relationships">
+<p:sld xmlns:a="http://schemas.openxmlformats.org/drawingml/2006/main" xmlns:r="http://schemas.openxmlformats.org/officeDocument/2006/relationships" xmlns:p="http://schemas.openxmlformats.org/presentationml/2006/main">
   <p:cSld>
     <p:bg>
       <p:bgPr>
@@ -10681,7 +10823,14 @@
         <p:cNvGrpSpPr/>
         <p:nvPr/>
       </p:nvGrpSpPr>
-      <p:grpSpPr/>
+      <p:grpSpPr>
+        <a:xfrm>
+          <a:off x="0" y="0"/>
+          <a:ext cx="0" cy="0"/>
+          <a:chOff x="0" y="0"/>
+          <a:chExt cx="0" cy="0"/>
+        </a:xfrm>
+      </p:grpSpPr>
       <p:sp>
         <p:nvSpPr>
           <p:cNvPr id="2" name="Rectangle 1"/>
@@ -10722,6 +10871,7 @@
           <a:lstStyle/>
           <a:p>
             <a:pPr algn="ctr"/>
+            <a:endParaRPr/>
           </a:p>
         </p:txBody>
       </p:sp>
@@ -10765,6 +10915,7 @@
           <a:lstStyle/>
           <a:p>
             <a:pPr algn="ctr"/>
+            <a:endParaRPr/>
           </a:p>
         </p:txBody>
       </p:sp>
@@ -10845,6 +10996,7 @@
           <a:lstStyle/>
           <a:p>
             <a:pPr algn="ctr"/>
+            <a:endParaRPr/>
           </a:p>
         </p:txBody>
       </p:sp>
@@ -10888,6 +11040,7 @@
           <a:lstStyle/>
           <a:p>
             <a:pPr algn="ctr"/>
+            <a:endParaRPr/>
           </a:p>
         </p:txBody>
       </p:sp>
@@ -11002,19 +11155,22 @@
           <a:lstStyle/>
           <a:p>
             <a:pPr algn="ctr"/>
-          </a:p>
-        </p:txBody>
-      </p:sp>
-      <p:sp>
-        <p:nvSpPr>
-          <p:cNvPr id="10" name="TextBox 9"/>
+            <a:endParaRPr/>
+          </a:p>
+        </p:txBody>
+      </p:sp>
+      <p:sp>
+        <p:nvSpPr>
+          <p:cNvPr id="10" name="TextBox 9">
+            <a:hlinkClick r:id="rId2"/>
+          </p:cNvPr>
           <p:cNvSpPr txBox="1"/>
           <p:nvPr/>
         </p:nvSpPr>
         <p:spPr>
           <a:xfrm>
-            <a:off x="822960" y="2743200"/>
-            <a:ext cx="4572000" cy="347472"/>
+            <a:off x="822960" y="2795275"/>
+            <a:ext cx="4572000" cy="261610"/>
           </a:xfrm>
           <a:prstGeom prst="rect">
             <a:avLst/>
@@ -11029,14 +11185,41 @@
           <a:p>
             <a:pPr algn="l"/>
             <a:r>
-              <a:rPr sz="1100" b="0" i="0">
+              <a:rPr lang="en-US" sz="1100" b="0" i="0" dirty="0">
                 <a:solidFill>
                   <a:srgbClr val="105BD8"/>
                 </a:solidFill>
                 <a:latin typeface="Consolas"/>
+                <a:hlinkClick r:id="rId2"/>
               </a:rPr>
-              <a:t>github.com/Luckyparihar11</a:t>
+              <a:t>Go</a:t>
             </a:r>
+            <a:r>
+              <a:rPr lang="en-US" sz="1100" dirty="0">
+                <a:solidFill>
+                  <a:srgbClr val="105BD8"/>
+                </a:solidFill>
+                <a:latin typeface="Consolas"/>
+                <a:hlinkClick r:id="rId2"/>
+              </a:rPr>
+              <a:t>-to-</a:t>
+            </a:r>
+            <a:r>
+              <a:rPr lang="en-US" sz="1100" dirty="0" err="1">
+                <a:solidFill>
+                  <a:srgbClr val="105BD8"/>
+                </a:solidFill>
+                <a:latin typeface="Consolas"/>
+                <a:hlinkClick r:id="rId2"/>
+              </a:rPr>
+              <a:t>github</a:t>
+            </a:r>
+            <a:endParaRPr sz="1100" b="0" i="0" dirty="0">
+              <a:solidFill>
+                <a:srgbClr val="105BD8"/>
+              </a:solidFill>
+              <a:latin typeface="Consolas"/>
+            </a:endParaRPr>
           </a:p>
         </p:txBody>
       </p:sp>
@@ -11082,6 +11265,7 @@
           <a:lstStyle/>
           <a:p>
             <a:pPr algn="ctr"/>
+            <a:endParaRPr/>
           </a:p>
         </p:txBody>
       </p:sp>
@@ -11125,6 +11309,7 @@
           <a:lstStyle/>
           <a:p>
             <a:pPr algn="ctr"/>
+            <a:endParaRPr/>
           </a:p>
         </p:txBody>
       </p:sp>
@@ -11239,6 +11424,7 @@
           <a:lstStyle/>
           <a:p>
             <a:pPr algn="ctr"/>
+            <a:endParaRPr/>
           </a:p>
         </p:txBody>
       </p:sp>
@@ -11251,7 +11437,7 @@
         <p:spPr>
           <a:xfrm>
             <a:off x="6583680" y="2743200"/>
-            <a:ext cx="4572000" cy="347472"/>
+            <a:ext cx="4572000" cy="261610"/>
           </a:xfrm>
           <a:prstGeom prst="rect">
             <a:avLst/>
@@ -11266,14 +11452,21 @@
           <a:p>
             <a:pPr algn="l"/>
             <a:r>
-              <a:rPr sz="1100" b="0" i="0">
+              <a:rPr sz="1100" b="0" i="0" dirty="0">
                 <a:solidFill>
                   <a:srgbClr val="10B981"/>
                 </a:solidFill>
                 <a:latin typeface="Consolas"/>
+                <a:hlinkClick r:id="rId3"/>
               </a:rPr>
-              <a:t>SharePoint Video Link</a:t>
+              <a:t>Video Link</a:t>
             </a:r>
+            <a:endParaRPr sz="1100" b="0" i="0" dirty="0">
+              <a:solidFill>
+                <a:srgbClr val="10B981"/>
+              </a:solidFill>
+              <a:latin typeface="Consolas"/>
+            </a:endParaRPr>
           </a:p>
         </p:txBody>
       </p:sp>
@@ -11352,6 +11545,7 @@
           <a:lstStyle/>
           <a:p>
             <a:pPr algn="ctr"/>
+            <a:endParaRPr/>
           </a:p>
         </p:txBody>
       </p:sp>
@@ -11395,6 +11589,7 @@
           <a:lstStyle/>
           <a:p>
             <a:pPr algn="ctr"/>
+            <a:endParaRPr/>
           </a:p>
         </p:txBody>
       </p:sp>
@@ -11508,6 +11703,7 @@
           <a:lstStyle/>
           <a:p>
             <a:pPr algn="ctr"/>
+            <a:endParaRPr/>
           </a:p>
         </p:txBody>
       </p:sp>
@@ -11621,6 +11817,7 @@
           <a:lstStyle/>
           <a:p>
             <a:pPr algn="ctr"/>
+            <a:endParaRPr/>
           </a:p>
         </p:txBody>
       </p:sp>
@@ -11703,7 +11900,7 @@
 </file>
 
 <file path=ppt/slides/slide7.xml><?xml version="1.0" encoding="utf-8"?>
-<p:sld xmlns:a="http://schemas.openxmlformats.org/drawingml/2006/main" xmlns:p="http://schemas.openxmlformats.org/presentationml/2006/main" xmlns:r="http://schemas.openxmlformats.org/officeDocument/2006/relationships">
+<p:sld xmlns:a="http://schemas.openxmlformats.org/drawingml/2006/main" xmlns:r="http://schemas.openxmlformats.org/officeDocument/2006/relationships" xmlns:p="http://schemas.openxmlformats.org/presentationml/2006/main">
   <p:cSld>
     <p:spTree>
       <p:nvGrpSpPr>
@@ -11711,7 +11908,14 @@
         <p:cNvGrpSpPr/>
         <p:nvPr/>
       </p:nvGrpSpPr>
-      <p:grpSpPr/>
+      <p:grpSpPr>
+        <a:xfrm>
+          <a:off x="0" y="0"/>
+          <a:ext cx="0" cy="0"/>
+          <a:chOff x="0" y="0"/>
+          <a:chExt cx="0" cy="0"/>
+        </a:xfrm>
+      </p:grpSpPr>
       <p:sp>
         <p:nvSpPr>
           <p:cNvPr id="2" name="Rectangle 1"/>
@@ -11752,6 +11956,7 @@
           <a:lstStyle/>
           <a:p>
             <a:pPr algn="ctr"/>
+            <a:endParaRPr/>
           </a:p>
         </p:txBody>
       </p:sp>
@@ -11795,6 +12000,7 @@
           <a:lstStyle/>
           <a:p>
             <a:pPr algn="ctr"/>
+            <a:endParaRPr/>
           </a:p>
         </p:txBody>
       </p:sp>
@@ -11838,6 +12044,7 @@
           <a:lstStyle/>
           <a:p>
             <a:pPr algn="ctr"/>
+            <a:endParaRPr/>
           </a:p>
         </p:txBody>
       </p:sp>
@@ -11881,6 +12088,7 @@
           <a:lstStyle/>
           <a:p>
             <a:pPr algn="ctr"/>
+            <a:endParaRPr/>
           </a:p>
         </p:txBody>
       </p:sp>
@@ -11924,6 +12132,7 @@
           <a:lstStyle/>
           <a:p>
             <a:pPr algn="ctr"/>
+            <a:endParaRPr/>
           </a:p>
         </p:txBody>
       </p:sp>
@@ -11967,6 +12176,7 @@
           <a:lstStyle/>
           <a:p>
             <a:pPr algn="ctr"/>
+            <a:endParaRPr/>
           </a:p>
         </p:txBody>
       </p:sp>
@@ -12010,6 +12220,7 @@
           <a:lstStyle/>
           <a:p>
             <a:pPr algn="ctr"/>
+            <a:endParaRPr/>
           </a:p>
         </p:txBody>
       </p:sp>
@@ -12053,6 +12264,7 @@
           <a:lstStyle/>
           <a:p>
             <a:pPr algn="ctr"/>
+            <a:endParaRPr/>
           </a:p>
         </p:txBody>
       </p:sp>
@@ -12096,6 +12308,7 @@
           <a:lstStyle/>
           <a:p>
             <a:pPr algn="ctr"/>
+            <a:endParaRPr/>
           </a:p>
         </p:txBody>
       </p:sp>
@@ -12139,6 +12352,7 @@
           <a:lstStyle/>
           <a:p>
             <a:pPr algn="ctr"/>
+            <a:endParaRPr/>
           </a:p>
         </p:txBody>
       </p:sp>
@@ -12182,6 +12396,7 @@
           <a:lstStyle/>
           <a:p>
             <a:pPr algn="ctr"/>
+            <a:endParaRPr/>
           </a:p>
         </p:txBody>
       </p:sp>
@@ -12225,6 +12440,7 @@
           <a:lstStyle/>
           <a:p>
             <a:pPr algn="ctr"/>
+            <a:endParaRPr/>
           </a:p>
         </p:txBody>
       </p:sp>
@@ -12268,6 +12484,7 @@
           <a:lstStyle/>
           <a:p>
             <a:pPr algn="ctr"/>
+            <a:endParaRPr/>
           </a:p>
         </p:txBody>
       </p:sp>
@@ -12311,6 +12528,7 @@
           <a:lstStyle/>
           <a:p>
             <a:pPr algn="ctr"/>
+            <a:endParaRPr/>
           </a:p>
         </p:txBody>
       </p:sp>
@@ -12354,6 +12572,7 @@
           <a:lstStyle/>
           <a:p>
             <a:pPr algn="ctr"/>
+            <a:endParaRPr/>
           </a:p>
         </p:txBody>
       </p:sp>
@@ -12397,6 +12616,7 @@
           <a:lstStyle/>
           <a:p>
             <a:pPr algn="ctr"/>
+            <a:endParaRPr/>
           </a:p>
         </p:txBody>
       </p:sp>
@@ -12440,6 +12660,7 @@
           <a:lstStyle/>
           <a:p>
             <a:pPr algn="ctr"/>
+            <a:endParaRPr/>
           </a:p>
         </p:txBody>
       </p:sp>
@@ -12483,6 +12704,7 @@
           <a:lstStyle/>
           <a:p>
             <a:pPr algn="ctr"/>
+            <a:endParaRPr/>
           </a:p>
         </p:txBody>
       </p:sp>
@@ -12526,6 +12748,7 @@
           <a:lstStyle/>
           <a:p>
             <a:pPr algn="ctr"/>
+            <a:endParaRPr/>
           </a:p>
         </p:txBody>
       </p:sp>
@@ -12569,6 +12792,7 @@
           <a:lstStyle/>
           <a:p>
             <a:pPr algn="ctr"/>
+            <a:endParaRPr/>
           </a:p>
         </p:txBody>
       </p:sp>
@@ -12612,6 +12836,7 @@
           <a:lstStyle/>
           <a:p>
             <a:pPr algn="ctr"/>
+            <a:endParaRPr/>
           </a:p>
         </p:txBody>
       </p:sp>
@@ -12655,6 +12880,7 @@
           <a:lstStyle/>
           <a:p>
             <a:pPr algn="ctr"/>
+            <a:endParaRPr/>
           </a:p>
         </p:txBody>
       </p:sp>
@@ -12698,6 +12924,7 @@
           <a:lstStyle/>
           <a:p>
             <a:pPr algn="ctr"/>
+            <a:endParaRPr/>
           </a:p>
         </p:txBody>
       </p:sp>
@@ -12741,6 +12968,7 @@
           <a:lstStyle/>
           <a:p>
             <a:pPr algn="ctr"/>
+            <a:endParaRPr/>
           </a:p>
         </p:txBody>
       </p:sp>
@@ -12784,6 +13012,7 @@
           <a:lstStyle/>
           <a:p>
             <a:pPr algn="ctr"/>
+            <a:endParaRPr/>
           </a:p>
         </p:txBody>
       </p:sp>
@@ -12827,6 +13056,7 @@
           <a:lstStyle/>
           <a:p>
             <a:pPr algn="ctr"/>
+            <a:endParaRPr/>
           </a:p>
         </p:txBody>
       </p:sp>
@@ -12870,6 +13100,7 @@
           <a:lstStyle/>
           <a:p>
             <a:pPr algn="ctr"/>
+            <a:endParaRPr/>
           </a:p>
         </p:txBody>
       </p:sp>
@@ -12913,6 +13144,7 @@
           <a:lstStyle/>
           <a:p>
             <a:pPr algn="ctr"/>
+            <a:endParaRPr/>
           </a:p>
         </p:txBody>
       </p:sp>
@@ -12956,6 +13188,7 @@
           <a:lstStyle/>
           <a:p>
             <a:pPr algn="ctr"/>
+            <a:endParaRPr/>
           </a:p>
         </p:txBody>
       </p:sp>
@@ -12999,6 +13232,7 @@
           <a:lstStyle/>
           <a:p>
             <a:pPr algn="ctr"/>
+            <a:endParaRPr/>
           </a:p>
         </p:txBody>
       </p:sp>
@@ -13042,6 +13276,7 @@
           <a:lstStyle/>
           <a:p>
             <a:pPr algn="ctr"/>
+            <a:endParaRPr/>
           </a:p>
         </p:txBody>
       </p:sp>
@@ -13085,6 +13320,7 @@
           <a:lstStyle/>
           <a:p>
             <a:pPr algn="ctr"/>
+            <a:endParaRPr/>
           </a:p>
         </p:txBody>
       </p:sp>
@@ -13128,6 +13364,7 @@
           <a:lstStyle/>
           <a:p>
             <a:pPr algn="ctr"/>
+            <a:endParaRPr/>
           </a:p>
         </p:txBody>
       </p:sp>
@@ -13171,6 +13408,7 @@
           <a:lstStyle/>
           <a:p>
             <a:pPr algn="ctr"/>
+            <a:endParaRPr/>
           </a:p>
         </p:txBody>
       </p:sp>
@@ -13214,6 +13452,7 @@
           <a:lstStyle/>
           <a:p>
             <a:pPr algn="ctr"/>
+            <a:endParaRPr/>
           </a:p>
         </p:txBody>
       </p:sp>
@@ -13257,6 +13496,7 @@
           <a:lstStyle/>
           <a:p>
             <a:pPr algn="ctr"/>
+            <a:endParaRPr/>
           </a:p>
         </p:txBody>
       </p:sp>
@@ -13300,6 +13540,7 @@
           <a:lstStyle/>
           <a:p>
             <a:pPr algn="ctr"/>
+            <a:endParaRPr/>
           </a:p>
         </p:txBody>
       </p:sp>
@@ -13343,6 +13584,7 @@
           <a:lstStyle/>
           <a:p>
             <a:pPr algn="ctr"/>
+            <a:endParaRPr/>
           </a:p>
         </p:txBody>
       </p:sp>
@@ -13386,6 +13628,7 @@
           <a:lstStyle/>
           <a:p>
             <a:pPr algn="ctr"/>
+            <a:endParaRPr/>
           </a:p>
         </p:txBody>
       </p:sp>
@@ -13429,6 +13672,7 @@
           <a:lstStyle/>
           <a:p>
             <a:pPr algn="ctr"/>
+            <a:endParaRPr/>
           </a:p>
         </p:txBody>
       </p:sp>
@@ -13472,6 +13716,7 @@
           <a:lstStyle/>
           <a:p>
             <a:pPr algn="ctr"/>
+            <a:endParaRPr/>
           </a:p>
         </p:txBody>
       </p:sp>
@@ -13515,6 +13760,7 @@
           <a:lstStyle/>
           <a:p>
             <a:pPr algn="ctr"/>
+            <a:endParaRPr/>
           </a:p>
         </p:txBody>
       </p:sp>
@@ -13558,6 +13804,7 @@
           <a:lstStyle/>
           <a:p>
             <a:pPr algn="ctr"/>
+            <a:endParaRPr/>
           </a:p>
         </p:txBody>
       </p:sp>
@@ -13601,6 +13848,7 @@
           <a:lstStyle/>
           <a:p>
             <a:pPr algn="ctr"/>
+            <a:endParaRPr/>
           </a:p>
         </p:txBody>
       </p:sp>
@@ -13644,6 +13892,7 @@
           <a:lstStyle/>
           <a:p>
             <a:pPr algn="ctr"/>
+            <a:endParaRPr/>
           </a:p>
         </p:txBody>
       </p:sp>
@@ -13687,6 +13936,7 @@
           <a:lstStyle/>
           <a:p>
             <a:pPr algn="ctr"/>
+            <a:endParaRPr/>
           </a:p>
         </p:txBody>
       </p:sp>
@@ -13730,6 +13980,7 @@
           <a:lstStyle/>
           <a:p>
             <a:pPr algn="ctr"/>
+            <a:endParaRPr/>
           </a:p>
         </p:txBody>
       </p:sp>
@@ -13773,6 +14024,7 @@
           <a:lstStyle/>
           <a:p>
             <a:pPr algn="ctr"/>
+            <a:endParaRPr/>
           </a:p>
         </p:txBody>
       </p:sp>
@@ -13816,6 +14068,7 @@
           <a:lstStyle/>
           <a:p>
             <a:pPr algn="ctr"/>
+            <a:endParaRPr/>
           </a:p>
         </p:txBody>
       </p:sp>
@@ -13859,6 +14112,7 @@
           <a:lstStyle/>
           <a:p>
             <a:pPr algn="ctr"/>
+            <a:endParaRPr/>
           </a:p>
         </p:txBody>
       </p:sp>
@@ -13902,6 +14156,7 @@
           <a:lstStyle/>
           <a:p>
             <a:pPr algn="ctr"/>
+            <a:endParaRPr/>
           </a:p>
         </p:txBody>
       </p:sp>
@@ -13945,6 +14200,7 @@
           <a:lstStyle/>
           <a:p>
             <a:pPr algn="ctr"/>
+            <a:endParaRPr/>
           </a:p>
         </p:txBody>
       </p:sp>
@@ -13988,6 +14244,7 @@
           <a:lstStyle/>
           <a:p>
             <a:pPr algn="ctr"/>
+            <a:endParaRPr/>
           </a:p>
         </p:txBody>
       </p:sp>
@@ -14031,6 +14288,7 @@
           <a:lstStyle/>
           <a:p>
             <a:pPr algn="ctr"/>
+            <a:endParaRPr/>
           </a:p>
         </p:txBody>
       </p:sp>
@@ -14074,6 +14332,7 @@
           <a:lstStyle/>
           <a:p>
             <a:pPr algn="ctr"/>
+            <a:endParaRPr/>
           </a:p>
         </p:txBody>
       </p:sp>
@@ -14117,6 +14376,7 @@
           <a:lstStyle/>
           <a:p>
             <a:pPr algn="ctr"/>
+            <a:endParaRPr/>
           </a:p>
         </p:txBody>
       </p:sp>
@@ -14160,6 +14420,7 @@
           <a:lstStyle/>
           <a:p>
             <a:pPr algn="ctr"/>
+            <a:endParaRPr/>
           </a:p>
         </p:txBody>
       </p:sp>
@@ -14203,6 +14464,7 @@
           <a:lstStyle/>
           <a:p>
             <a:pPr algn="ctr"/>
+            <a:endParaRPr/>
           </a:p>
         </p:txBody>
       </p:sp>
@@ -14246,6 +14508,7 @@
           <a:lstStyle/>
           <a:p>
             <a:pPr algn="ctr"/>
+            <a:endParaRPr/>
           </a:p>
         </p:txBody>
       </p:sp>
@@ -14289,6 +14552,7 @@
           <a:lstStyle/>
           <a:p>
             <a:pPr algn="ctr"/>
+            <a:endParaRPr/>
           </a:p>
         </p:txBody>
       </p:sp>
@@ -14332,6 +14596,7 @@
           <a:lstStyle/>
           <a:p>
             <a:pPr algn="ctr"/>
+            <a:endParaRPr/>
           </a:p>
         </p:txBody>
       </p:sp>
@@ -14375,6 +14640,7 @@
           <a:lstStyle/>
           <a:p>
             <a:pPr algn="ctr"/>
+            <a:endParaRPr/>
           </a:p>
         </p:txBody>
       </p:sp>
@@ -14418,6 +14684,7 @@
           <a:lstStyle/>
           <a:p>
             <a:pPr algn="ctr"/>
+            <a:endParaRPr/>
           </a:p>
         </p:txBody>
       </p:sp>
@@ -14461,6 +14728,7 @@
           <a:lstStyle/>
           <a:p>
             <a:pPr algn="ctr"/>
+            <a:endParaRPr/>
           </a:p>
         </p:txBody>
       </p:sp>
@@ -14504,6 +14772,7 @@
           <a:lstStyle/>
           <a:p>
             <a:pPr algn="ctr"/>
+            <a:endParaRPr/>
           </a:p>
         </p:txBody>
       </p:sp>
@@ -14547,6 +14816,7 @@
           <a:lstStyle/>
           <a:p>
             <a:pPr algn="ctr"/>
+            <a:endParaRPr/>
           </a:p>
         </p:txBody>
       </p:sp>
@@ -14590,6 +14860,7 @@
           <a:lstStyle/>
           <a:p>
             <a:pPr algn="ctr"/>
+            <a:endParaRPr/>
           </a:p>
         </p:txBody>
       </p:sp>
@@ -14633,6 +14904,7 @@
           <a:lstStyle/>
           <a:p>
             <a:pPr algn="ctr"/>
+            <a:endParaRPr/>
           </a:p>
         </p:txBody>
       </p:sp>
@@ -14676,6 +14948,7 @@
           <a:lstStyle/>
           <a:p>
             <a:pPr algn="ctr"/>
+            <a:endParaRPr/>
           </a:p>
         </p:txBody>
       </p:sp>
@@ -14719,6 +14992,7 @@
           <a:lstStyle/>
           <a:p>
             <a:pPr algn="ctr"/>
+            <a:endParaRPr/>
           </a:p>
         </p:txBody>
       </p:sp>
@@ -14762,6 +15036,7 @@
           <a:lstStyle/>
           <a:p>
             <a:pPr algn="ctr"/>
+            <a:endParaRPr/>
           </a:p>
         </p:txBody>
       </p:sp>
@@ -14805,6 +15080,7 @@
           <a:lstStyle/>
           <a:p>
             <a:pPr algn="ctr"/>
+            <a:endParaRPr/>
           </a:p>
         </p:txBody>
       </p:sp>
@@ -14848,6 +15124,7 @@
           <a:lstStyle/>
           <a:p>
             <a:pPr algn="ctr"/>
+            <a:endParaRPr/>
           </a:p>
         </p:txBody>
       </p:sp>
@@ -14891,6 +15168,7 @@
           <a:lstStyle/>
           <a:p>
             <a:pPr algn="ctr"/>
+            <a:endParaRPr/>
           </a:p>
         </p:txBody>
       </p:sp>
@@ -14934,6 +15212,7 @@
           <a:lstStyle/>
           <a:p>
             <a:pPr algn="ctr"/>
+            <a:endParaRPr/>
           </a:p>
         </p:txBody>
       </p:sp>
@@ -14977,6 +15256,7 @@
           <a:lstStyle/>
           <a:p>
             <a:pPr algn="ctr"/>
+            <a:endParaRPr/>
           </a:p>
         </p:txBody>
       </p:sp>
@@ -15020,6 +15300,7 @@
           <a:lstStyle/>
           <a:p>
             <a:pPr algn="ctr"/>
+            <a:endParaRPr/>
           </a:p>
         </p:txBody>
       </p:sp>
@@ -15063,6 +15344,7 @@
           <a:lstStyle/>
           <a:p>
             <a:pPr algn="ctr"/>
+            <a:endParaRPr/>
           </a:p>
         </p:txBody>
       </p:sp>
@@ -15106,6 +15388,7 @@
           <a:lstStyle/>
           <a:p>
             <a:pPr algn="ctr"/>
+            <a:endParaRPr/>
           </a:p>
         </p:txBody>
       </p:sp>
@@ -15149,6 +15432,7 @@
           <a:lstStyle/>
           <a:p>
             <a:pPr algn="ctr"/>
+            <a:endParaRPr/>
           </a:p>
         </p:txBody>
       </p:sp>
@@ -15192,6 +15476,7 @@
           <a:lstStyle/>
           <a:p>
             <a:pPr algn="ctr"/>
+            <a:endParaRPr/>
           </a:p>
         </p:txBody>
       </p:sp>
@@ -15235,6 +15520,7 @@
           <a:lstStyle/>
           <a:p>
             <a:pPr algn="ctr"/>
+            <a:endParaRPr/>
           </a:p>
         </p:txBody>
       </p:sp>
@@ -15278,6 +15564,7 @@
           <a:lstStyle/>
           <a:p>
             <a:pPr algn="ctr"/>
+            <a:endParaRPr/>
           </a:p>
         </p:txBody>
       </p:sp>
@@ -15321,6 +15608,7 @@
           <a:lstStyle/>
           <a:p>
             <a:pPr algn="ctr"/>
+            <a:endParaRPr/>
           </a:p>
         </p:txBody>
       </p:sp>
@@ -15364,6 +15652,7 @@
           <a:lstStyle/>
           <a:p>
             <a:pPr algn="ctr"/>
+            <a:endParaRPr/>
           </a:p>
         </p:txBody>
       </p:sp>
@@ -15407,6 +15696,7 @@
           <a:lstStyle/>
           <a:p>
             <a:pPr algn="ctr"/>
+            <a:endParaRPr/>
           </a:p>
         </p:txBody>
       </p:sp>
@@ -15450,6 +15740,7 @@
           <a:lstStyle/>
           <a:p>
             <a:pPr algn="ctr"/>
+            <a:endParaRPr/>
           </a:p>
         </p:txBody>
       </p:sp>
@@ -15493,6 +15784,7 @@
           <a:lstStyle/>
           <a:p>
             <a:pPr algn="ctr"/>
+            <a:endParaRPr/>
           </a:p>
         </p:txBody>
       </p:sp>
@@ -15536,6 +15828,7 @@
           <a:lstStyle/>
           <a:p>
             <a:pPr algn="ctr"/>
+            <a:endParaRPr/>
           </a:p>
         </p:txBody>
       </p:sp>
@@ -15579,6 +15872,7 @@
           <a:lstStyle/>
           <a:p>
             <a:pPr algn="ctr"/>
+            <a:endParaRPr/>
           </a:p>
         </p:txBody>
       </p:sp>
@@ -15622,6 +15916,7 @@
           <a:lstStyle/>
           <a:p>
             <a:pPr algn="ctr"/>
+            <a:endParaRPr/>
           </a:p>
         </p:txBody>
       </p:sp>
@@ -15665,6 +15960,7 @@
           <a:lstStyle/>
           <a:p>
             <a:pPr algn="ctr"/>
+            <a:endParaRPr/>
           </a:p>
         </p:txBody>
       </p:sp>
@@ -15708,6 +16004,7 @@
           <a:lstStyle/>
           <a:p>
             <a:pPr algn="ctr"/>
+            <a:endParaRPr/>
           </a:p>
         </p:txBody>
       </p:sp>
@@ -15751,6 +16048,7 @@
           <a:lstStyle/>
           <a:p>
             <a:pPr algn="ctr"/>
+            <a:endParaRPr/>
           </a:p>
         </p:txBody>
       </p:sp>
@@ -15794,6 +16092,7 @@
           <a:lstStyle/>
           <a:p>
             <a:pPr algn="ctr"/>
+            <a:endParaRPr/>
           </a:p>
         </p:txBody>
       </p:sp>
@@ -15837,6 +16136,7 @@
           <a:lstStyle/>
           <a:p>
             <a:pPr algn="ctr"/>
+            <a:endParaRPr/>
           </a:p>
         </p:txBody>
       </p:sp>
@@ -15880,6 +16180,7 @@
           <a:lstStyle/>
           <a:p>
             <a:pPr algn="ctr"/>
+            <a:endParaRPr/>
           </a:p>
         </p:txBody>
       </p:sp>
@@ -15923,6 +16224,7 @@
           <a:lstStyle/>
           <a:p>
             <a:pPr algn="ctr"/>
+            <a:endParaRPr/>
           </a:p>
         </p:txBody>
       </p:sp>
@@ -15966,6 +16268,7 @@
           <a:lstStyle/>
           <a:p>
             <a:pPr algn="ctr"/>
+            <a:endParaRPr/>
           </a:p>
         </p:txBody>
       </p:sp>
@@ -16009,6 +16312,7 @@
           <a:lstStyle/>
           <a:p>
             <a:pPr algn="ctr"/>
+            <a:endParaRPr/>
           </a:p>
         </p:txBody>
       </p:sp>
@@ -16052,6 +16356,7 @@
           <a:lstStyle/>
           <a:p>
             <a:pPr algn="ctr"/>
+            <a:endParaRPr/>
           </a:p>
         </p:txBody>
       </p:sp>
@@ -16095,6 +16400,7 @@
           <a:lstStyle/>
           <a:p>
             <a:pPr algn="ctr"/>
+            <a:endParaRPr/>
           </a:p>
         </p:txBody>
       </p:sp>
@@ -16138,6 +16444,7 @@
           <a:lstStyle/>
           <a:p>
             <a:pPr algn="ctr"/>
+            <a:endParaRPr/>
           </a:p>
         </p:txBody>
       </p:sp>
@@ -16181,6 +16488,7 @@
           <a:lstStyle/>
           <a:p>
             <a:pPr algn="ctr"/>
+            <a:endParaRPr/>
           </a:p>
         </p:txBody>
       </p:sp>
@@ -16224,6 +16532,7 @@
           <a:lstStyle/>
           <a:p>
             <a:pPr algn="ctr"/>
+            <a:endParaRPr/>
           </a:p>
         </p:txBody>
       </p:sp>
@@ -16267,6 +16576,7 @@
           <a:lstStyle/>
           <a:p>
             <a:pPr algn="ctr"/>
+            <a:endParaRPr/>
           </a:p>
         </p:txBody>
       </p:sp>
@@ -16310,6 +16620,7 @@
           <a:lstStyle/>
           <a:p>
             <a:pPr algn="ctr"/>
+            <a:endParaRPr/>
           </a:p>
         </p:txBody>
       </p:sp>
@@ -16353,6 +16664,7 @@
           <a:lstStyle/>
           <a:p>
             <a:pPr algn="ctr"/>
+            <a:endParaRPr/>
           </a:p>
         </p:txBody>
       </p:sp>
@@ -16396,6 +16708,7 @@
           <a:lstStyle/>
           <a:p>
             <a:pPr algn="ctr"/>
+            <a:endParaRPr/>
           </a:p>
         </p:txBody>
       </p:sp>
@@ -16439,6 +16752,7 @@
           <a:lstStyle/>
           <a:p>
             <a:pPr algn="ctr"/>
+            <a:endParaRPr/>
           </a:p>
         </p:txBody>
       </p:sp>
@@ -16482,6 +16796,7 @@
           <a:lstStyle/>
           <a:p>
             <a:pPr algn="ctr"/>
+            <a:endParaRPr/>
           </a:p>
         </p:txBody>
       </p:sp>
@@ -16525,6 +16840,7 @@
           <a:lstStyle/>
           <a:p>
             <a:pPr algn="ctr"/>
+            <a:endParaRPr/>
           </a:p>
         </p:txBody>
       </p:sp>
@@ -16568,6 +16884,7 @@
           <a:lstStyle/>
           <a:p>
             <a:pPr algn="ctr"/>
+            <a:endParaRPr/>
           </a:p>
         </p:txBody>
       </p:sp>
@@ -16611,6 +16928,7 @@
           <a:lstStyle/>
           <a:p>
             <a:pPr algn="ctr"/>
+            <a:endParaRPr/>
           </a:p>
         </p:txBody>
       </p:sp>
@@ -16654,6 +16972,7 @@
           <a:lstStyle/>
           <a:p>
             <a:pPr algn="ctr"/>
+            <a:endParaRPr/>
           </a:p>
         </p:txBody>
       </p:sp>
@@ -16697,6 +17016,7 @@
           <a:lstStyle/>
           <a:p>
             <a:pPr algn="ctr"/>
+            <a:endParaRPr/>
           </a:p>
         </p:txBody>
       </p:sp>
@@ -16740,6 +17060,7 @@
           <a:lstStyle/>
           <a:p>
             <a:pPr algn="ctr"/>
+            <a:endParaRPr/>
           </a:p>
         </p:txBody>
       </p:sp>
@@ -16783,6 +17104,7 @@
           <a:lstStyle/>
           <a:p>
             <a:pPr algn="ctr"/>
+            <a:endParaRPr/>
           </a:p>
         </p:txBody>
       </p:sp>
@@ -16826,6 +17148,7 @@
           <a:lstStyle/>
           <a:p>
             <a:pPr algn="ctr"/>
+            <a:endParaRPr/>
           </a:p>
         </p:txBody>
       </p:sp>
@@ -16869,6 +17192,7 @@
           <a:lstStyle/>
           <a:p>
             <a:pPr algn="ctr"/>
+            <a:endParaRPr/>
           </a:p>
         </p:txBody>
       </p:sp>
@@ -16912,6 +17236,7 @@
           <a:lstStyle/>
           <a:p>
             <a:pPr algn="ctr"/>
+            <a:endParaRPr/>
           </a:p>
         </p:txBody>
       </p:sp>
@@ -16955,6 +17280,7 @@
           <a:lstStyle/>
           <a:p>
             <a:pPr algn="ctr"/>
+            <a:endParaRPr/>
           </a:p>
         </p:txBody>
       </p:sp>
@@ -16998,6 +17324,7 @@
           <a:lstStyle/>
           <a:p>
             <a:pPr algn="ctr"/>
+            <a:endParaRPr/>
           </a:p>
         </p:txBody>
       </p:sp>
@@ -17041,6 +17368,7 @@
           <a:lstStyle/>
           <a:p>
             <a:pPr algn="ctr"/>
+            <a:endParaRPr/>
           </a:p>
         </p:txBody>
       </p:sp>
@@ -17084,6 +17412,7 @@
           <a:lstStyle/>
           <a:p>
             <a:pPr algn="ctr"/>
+            <a:endParaRPr/>
           </a:p>
         </p:txBody>
       </p:sp>
@@ -17127,6 +17456,7 @@
           <a:lstStyle/>
           <a:p>
             <a:pPr algn="ctr"/>
+            <a:endParaRPr/>
           </a:p>
         </p:txBody>
       </p:sp>
@@ -17170,6 +17500,7 @@
           <a:lstStyle/>
           <a:p>
             <a:pPr algn="ctr"/>
+            <a:endParaRPr/>
           </a:p>
         </p:txBody>
       </p:sp>
@@ -17213,6 +17544,7 @@
           <a:lstStyle/>
           <a:p>
             <a:pPr algn="ctr"/>
+            <a:endParaRPr/>
           </a:p>
         </p:txBody>
       </p:sp>
@@ -17256,6 +17588,7 @@
           <a:lstStyle/>
           <a:p>
             <a:pPr algn="ctr"/>
+            <a:endParaRPr/>
           </a:p>
         </p:txBody>
       </p:sp>
@@ -17299,6 +17632,7 @@
           <a:lstStyle/>
           <a:p>
             <a:pPr algn="ctr"/>
+            <a:endParaRPr/>
           </a:p>
         </p:txBody>
       </p:sp>
@@ -17342,6 +17676,7 @@
           <a:lstStyle/>
           <a:p>
             <a:pPr algn="ctr"/>
+            <a:endParaRPr/>
           </a:p>
         </p:txBody>
       </p:sp>
@@ -17385,6 +17720,7 @@
           <a:lstStyle/>
           <a:p>
             <a:pPr algn="ctr"/>
+            <a:endParaRPr/>
           </a:p>
         </p:txBody>
       </p:sp>
@@ -17428,6 +17764,7 @@
           <a:lstStyle/>
           <a:p>
             <a:pPr algn="ctr"/>
+            <a:endParaRPr/>
           </a:p>
         </p:txBody>
       </p:sp>
@@ -17471,6 +17808,7 @@
           <a:lstStyle/>
           <a:p>
             <a:pPr algn="ctr"/>
+            <a:endParaRPr/>
           </a:p>
         </p:txBody>
       </p:sp>
@@ -17514,6 +17852,7 @@
           <a:lstStyle/>
           <a:p>
             <a:pPr algn="ctr"/>
+            <a:endParaRPr/>
           </a:p>
         </p:txBody>
       </p:sp>
@@ -17557,6 +17896,7 @@
           <a:lstStyle/>
           <a:p>
             <a:pPr algn="ctr"/>
+            <a:endParaRPr/>
           </a:p>
         </p:txBody>
       </p:sp>
@@ -17600,6 +17940,7 @@
           <a:lstStyle/>
           <a:p>
             <a:pPr algn="ctr"/>
+            <a:endParaRPr/>
           </a:p>
         </p:txBody>
       </p:sp>
@@ -17643,6 +17984,7 @@
           <a:lstStyle/>
           <a:p>
             <a:pPr algn="ctr"/>
+            <a:endParaRPr/>
           </a:p>
         </p:txBody>
       </p:sp>
@@ -17686,6 +18028,7 @@
           <a:lstStyle/>
           <a:p>
             <a:pPr algn="ctr"/>
+            <a:endParaRPr/>
           </a:p>
         </p:txBody>
       </p:sp>
@@ -17729,6 +18072,7 @@
           <a:lstStyle/>
           <a:p>
             <a:pPr algn="ctr"/>
+            <a:endParaRPr/>
           </a:p>
         </p:txBody>
       </p:sp>
@@ -17772,6 +18116,7 @@
           <a:lstStyle/>
           <a:p>
             <a:pPr algn="ctr"/>
+            <a:endParaRPr/>
           </a:p>
         </p:txBody>
       </p:sp>
@@ -17815,6 +18160,7 @@
           <a:lstStyle/>
           <a:p>
             <a:pPr algn="ctr"/>
+            <a:endParaRPr/>
           </a:p>
         </p:txBody>
       </p:sp>
@@ -17858,6 +18204,7 @@
           <a:lstStyle/>
           <a:p>
             <a:pPr algn="ctr"/>
+            <a:endParaRPr/>
           </a:p>
         </p:txBody>
       </p:sp>
@@ -17901,6 +18248,7 @@
           <a:lstStyle/>
           <a:p>
             <a:pPr algn="ctr"/>
+            <a:endParaRPr/>
           </a:p>
         </p:txBody>
       </p:sp>
@@ -17944,6 +18292,7 @@
           <a:lstStyle/>
           <a:p>
             <a:pPr algn="ctr"/>
+            <a:endParaRPr/>
           </a:p>
         </p:txBody>
       </p:sp>
@@ -17987,6 +18336,7 @@
           <a:lstStyle/>
           <a:p>
             <a:pPr algn="ctr"/>
+            <a:endParaRPr/>
           </a:p>
         </p:txBody>
       </p:sp>
@@ -18030,6 +18380,7 @@
           <a:lstStyle/>
           <a:p>
             <a:pPr algn="ctr"/>
+            <a:endParaRPr/>
           </a:p>
         </p:txBody>
       </p:sp>
@@ -18073,6 +18424,7 @@
           <a:lstStyle/>
           <a:p>
             <a:pPr algn="ctr"/>
+            <a:endParaRPr/>
           </a:p>
         </p:txBody>
       </p:sp>
@@ -18116,6 +18468,7 @@
           <a:lstStyle/>
           <a:p>
             <a:pPr algn="ctr"/>
+            <a:endParaRPr/>
           </a:p>
         </p:txBody>
       </p:sp>
@@ -18159,6 +18512,7 @@
           <a:lstStyle/>
           <a:p>
             <a:pPr algn="ctr"/>
+            <a:endParaRPr/>
           </a:p>
         </p:txBody>
       </p:sp>
@@ -18202,6 +18556,7 @@
           <a:lstStyle/>
           <a:p>
             <a:pPr algn="ctr"/>
+            <a:endParaRPr/>
           </a:p>
         </p:txBody>
       </p:sp>
@@ -18245,6 +18600,7 @@
           <a:lstStyle/>
           <a:p>
             <a:pPr algn="ctr"/>
+            <a:endParaRPr/>
           </a:p>
         </p:txBody>
       </p:sp>
@@ -18288,6 +18644,7 @@
           <a:lstStyle/>
           <a:p>
             <a:pPr algn="ctr"/>
+            <a:endParaRPr/>
           </a:p>
         </p:txBody>
       </p:sp>
@@ -18331,6 +18688,7 @@
           <a:lstStyle/>
           <a:p>
             <a:pPr algn="ctr"/>
+            <a:endParaRPr/>
           </a:p>
         </p:txBody>
       </p:sp>
@@ -18374,6 +18732,7 @@
           <a:lstStyle/>
           <a:p>
             <a:pPr algn="ctr"/>
+            <a:endParaRPr/>
           </a:p>
         </p:txBody>
       </p:sp>
@@ -18417,6 +18776,7 @@
           <a:lstStyle/>
           <a:p>
             <a:pPr algn="ctr"/>
+            <a:endParaRPr/>
           </a:p>
         </p:txBody>
       </p:sp>
@@ -18460,6 +18820,7 @@
           <a:lstStyle/>
           <a:p>
             <a:pPr algn="ctr"/>
+            <a:endParaRPr/>
           </a:p>
         </p:txBody>
       </p:sp>
@@ -18503,6 +18864,7 @@
           <a:lstStyle/>
           <a:p>
             <a:pPr algn="ctr"/>
+            <a:endParaRPr/>
           </a:p>
         </p:txBody>
       </p:sp>
@@ -18546,6 +18908,7 @@
           <a:lstStyle/>
           <a:p>
             <a:pPr algn="ctr"/>
+            <a:endParaRPr/>
           </a:p>
         </p:txBody>
       </p:sp>
@@ -18589,6 +18952,7 @@
           <a:lstStyle/>
           <a:p>
             <a:pPr algn="ctr"/>
+            <a:endParaRPr/>
           </a:p>
         </p:txBody>
       </p:sp>
@@ -18632,6 +18996,7 @@
           <a:lstStyle/>
           <a:p>
             <a:pPr algn="ctr"/>
+            <a:endParaRPr/>
           </a:p>
         </p:txBody>
       </p:sp>
@@ -18675,6 +19040,7 @@
           <a:lstStyle/>
           <a:p>
             <a:pPr algn="ctr"/>
+            <a:endParaRPr/>
           </a:p>
         </p:txBody>
       </p:sp>
@@ -18718,6 +19084,7 @@
           <a:lstStyle/>
           <a:p>
             <a:pPr algn="ctr"/>
+            <a:endParaRPr/>
           </a:p>
         </p:txBody>
       </p:sp>
@@ -18761,6 +19128,7 @@
           <a:lstStyle/>
           <a:p>
             <a:pPr algn="ctr"/>
+            <a:endParaRPr/>
           </a:p>
         </p:txBody>
       </p:sp>
@@ -18804,6 +19172,7 @@
           <a:lstStyle/>
           <a:p>
             <a:pPr algn="ctr"/>
+            <a:endParaRPr/>
           </a:p>
         </p:txBody>
       </p:sp>
@@ -18847,6 +19216,7 @@
           <a:lstStyle/>
           <a:p>
             <a:pPr algn="ctr"/>
+            <a:endParaRPr/>
           </a:p>
         </p:txBody>
       </p:sp>
@@ -18890,6 +19260,7 @@
           <a:lstStyle/>
           <a:p>
             <a:pPr algn="ctr"/>
+            <a:endParaRPr/>
           </a:p>
         </p:txBody>
       </p:sp>
@@ -18933,6 +19304,7 @@
           <a:lstStyle/>
           <a:p>
             <a:pPr algn="ctr"/>
+            <a:endParaRPr/>
           </a:p>
         </p:txBody>
       </p:sp>
@@ -18976,6 +19348,7 @@
           <a:lstStyle/>
           <a:p>
             <a:pPr algn="ctr"/>
+            <a:endParaRPr/>
           </a:p>
         </p:txBody>
       </p:sp>
@@ -19019,6 +19392,7 @@
           <a:lstStyle/>
           <a:p>
             <a:pPr algn="ctr"/>
+            <a:endParaRPr/>
           </a:p>
         </p:txBody>
       </p:sp>
@@ -19062,6 +19436,7 @@
           <a:lstStyle/>
           <a:p>
             <a:pPr algn="ctr"/>
+            <a:endParaRPr/>
           </a:p>
         </p:txBody>
       </p:sp>
@@ -19105,6 +19480,7 @@
           <a:lstStyle/>
           <a:p>
             <a:pPr algn="ctr"/>
+            <a:endParaRPr/>
           </a:p>
         </p:txBody>
       </p:sp>
@@ -19148,6 +19524,7 @@
           <a:lstStyle/>
           <a:p>
             <a:pPr algn="ctr"/>
+            <a:endParaRPr/>
           </a:p>
         </p:txBody>
       </p:sp>
@@ -19191,6 +19568,7 @@
           <a:lstStyle/>
           <a:p>
             <a:pPr algn="ctr"/>
+            <a:endParaRPr/>
           </a:p>
         </p:txBody>
       </p:sp>
@@ -19234,6 +19612,7 @@
           <a:lstStyle/>
           <a:p>
             <a:pPr algn="ctr"/>
+            <a:endParaRPr/>
           </a:p>
         </p:txBody>
       </p:sp>
@@ -19277,6 +19656,7 @@
           <a:lstStyle/>
           <a:p>
             <a:pPr algn="ctr"/>
+            <a:endParaRPr/>
           </a:p>
         </p:txBody>
       </p:sp>
@@ -19320,6 +19700,7 @@
           <a:lstStyle/>
           <a:p>
             <a:pPr algn="ctr"/>
+            <a:endParaRPr/>
           </a:p>
         </p:txBody>
       </p:sp>
@@ -19363,6 +19744,7 @@
           <a:lstStyle/>
           <a:p>
             <a:pPr algn="ctr"/>
+            <a:endParaRPr/>
           </a:p>
         </p:txBody>
       </p:sp>
@@ -19406,6 +19788,7 @@
           <a:lstStyle/>
           <a:p>
             <a:pPr algn="ctr"/>
+            <a:endParaRPr/>
           </a:p>
         </p:txBody>
       </p:sp>
@@ -19449,6 +19832,7 @@
           <a:lstStyle/>
           <a:p>
             <a:pPr algn="ctr"/>
+            <a:endParaRPr/>
           </a:p>
         </p:txBody>
       </p:sp>
@@ -19492,6 +19876,7 @@
           <a:lstStyle/>
           <a:p>
             <a:pPr algn="ctr"/>
+            <a:endParaRPr/>
           </a:p>
         </p:txBody>
       </p:sp>
@@ -19535,6 +19920,7 @@
           <a:lstStyle/>
           <a:p>
             <a:pPr algn="ctr"/>
+            <a:endParaRPr/>
           </a:p>
         </p:txBody>
       </p:sp>
@@ -19578,6 +19964,7 @@
           <a:lstStyle/>
           <a:p>
             <a:pPr algn="ctr"/>
+            <a:endParaRPr/>
           </a:p>
         </p:txBody>
       </p:sp>
@@ -19621,6 +20008,7 @@
           <a:lstStyle/>
           <a:p>
             <a:pPr algn="ctr"/>
+            <a:endParaRPr/>
           </a:p>
         </p:txBody>
       </p:sp>
@@ -19664,6 +20052,7 @@
           <a:lstStyle/>
           <a:p>
             <a:pPr algn="ctr"/>
+            <a:endParaRPr/>
           </a:p>
         </p:txBody>
       </p:sp>
@@ -19707,6 +20096,7 @@
           <a:lstStyle/>
           <a:p>
             <a:pPr algn="ctr"/>
+            <a:endParaRPr/>
           </a:p>
         </p:txBody>
       </p:sp>
@@ -19750,6 +20140,7 @@
           <a:lstStyle/>
           <a:p>
             <a:pPr algn="ctr"/>
+            <a:endParaRPr/>
           </a:p>
         </p:txBody>
       </p:sp>
@@ -19793,6 +20184,7 @@
           <a:lstStyle/>
           <a:p>
             <a:pPr algn="ctr"/>
+            <a:endParaRPr/>
           </a:p>
         </p:txBody>
       </p:sp>
@@ -19836,6 +20228,7 @@
           <a:lstStyle/>
           <a:p>
             <a:pPr algn="ctr"/>
+            <a:endParaRPr/>
           </a:p>
         </p:txBody>
       </p:sp>
@@ -19879,6 +20272,7 @@
           <a:lstStyle/>
           <a:p>
             <a:pPr algn="ctr"/>
+            <a:endParaRPr/>
           </a:p>
         </p:txBody>
       </p:sp>
@@ -19922,6 +20316,7 @@
           <a:lstStyle/>
           <a:p>
             <a:pPr algn="ctr"/>
+            <a:endParaRPr/>
           </a:p>
         </p:txBody>
       </p:sp>
@@ -19965,6 +20360,7 @@
           <a:lstStyle/>
           <a:p>
             <a:pPr algn="ctr"/>
+            <a:endParaRPr/>
           </a:p>
         </p:txBody>
       </p:sp>
@@ -20008,6 +20404,7 @@
           <a:lstStyle/>
           <a:p>
             <a:pPr algn="ctr"/>
+            <a:endParaRPr/>
           </a:p>
         </p:txBody>
       </p:sp>
@@ -20051,6 +20448,7 @@
           <a:lstStyle/>
           <a:p>
             <a:pPr algn="ctr"/>
+            <a:endParaRPr/>
           </a:p>
         </p:txBody>
       </p:sp>
@@ -20094,6 +20492,7 @@
           <a:lstStyle/>
           <a:p>
             <a:pPr algn="ctr"/>
+            <a:endParaRPr/>
           </a:p>
         </p:txBody>
       </p:sp>
@@ -20137,6 +20536,7 @@
           <a:lstStyle/>
           <a:p>
             <a:pPr algn="ctr"/>
+            <a:endParaRPr/>
           </a:p>
         </p:txBody>
       </p:sp>
@@ -20180,6 +20580,7 @@
           <a:lstStyle/>
           <a:p>
             <a:pPr algn="ctr"/>
+            <a:endParaRPr/>
           </a:p>
         </p:txBody>
       </p:sp>
@@ -20223,6 +20624,7 @@
           <a:lstStyle/>
           <a:p>
             <a:pPr algn="ctr"/>
+            <a:endParaRPr/>
           </a:p>
         </p:txBody>
       </p:sp>
@@ -20266,6 +20668,7 @@
           <a:lstStyle/>
           <a:p>
             <a:pPr algn="ctr"/>
+            <a:endParaRPr/>
           </a:p>
         </p:txBody>
       </p:sp>
@@ -20309,6 +20712,7 @@
           <a:lstStyle/>
           <a:p>
             <a:pPr algn="ctr"/>
+            <a:endParaRPr/>
           </a:p>
         </p:txBody>
       </p:sp>
@@ -20352,6 +20756,7 @@
           <a:lstStyle/>
           <a:p>
             <a:pPr algn="ctr"/>
+            <a:endParaRPr/>
           </a:p>
         </p:txBody>
       </p:sp>
@@ -20395,6 +20800,7 @@
           <a:lstStyle/>
           <a:p>
             <a:pPr algn="ctr"/>
+            <a:endParaRPr/>
           </a:p>
         </p:txBody>
       </p:sp>
@@ -20438,6 +20844,7 @@
           <a:lstStyle/>
           <a:p>
             <a:pPr algn="ctr"/>
+            <a:endParaRPr/>
           </a:p>
         </p:txBody>
       </p:sp>
@@ -20481,6 +20888,7 @@
           <a:lstStyle/>
           <a:p>
             <a:pPr algn="ctr"/>
+            <a:endParaRPr/>
           </a:p>
         </p:txBody>
       </p:sp>
@@ -20524,6 +20932,7 @@
           <a:lstStyle/>
           <a:p>
             <a:pPr algn="ctr"/>
+            <a:endParaRPr/>
           </a:p>
         </p:txBody>
       </p:sp>
@@ -20567,6 +20976,7 @@
           <a:lstStyle/>
           <a:p>
             <a:pPr algn="ctr"/>
+            <a:endParaRPr/>
           </a:p>
         </p:txBody>
       </p:sp>
@@ -20610,6 +21020,7 @@
           <a:lstStyle/>
           <a:p>
             <a:pPr algn="ctr"/>
+            <a:endParaRPr/>
           </a:p>
         </p:txBody>
       </p:sp>
@@ -20653,6 +21064,7 @@
           <a:lstStyle/>
           <a:p>
             <a:pPr algn="ctr"/>
+            <a:endParaRPr/>
           </a:p>
         </p:txBody>
       </p:sp>
@@ -20696,6 +21108,7 @@
           <a:lstStyle/>
           <a:p>
             <a:pPr algn="ctr"/>
+            <a:endParaRPr/>
           </a:p>
         </p:txBody>
       </p:sp>
@@ -20739,6 +21152,7 @@
           <a:lstStyle/>
           <a:p>
             <a:pPr algn="ctr"/>
+            <a:endParaRPr/>
           </a:p>
         </p:txBody>
       </p:sp>
@@ -20782,6 +21196,7 @@
           <a:lstStyle/>
           <a:p>
             <a:pPr algn="ctr"/>
+            <a:endParaRPr/>
           </a:p>
         </p:txBody>
       </p:sp>
@@ -20825,6 +21240,7 @@
           <a:lstStyle/>
           <a:p>
             <a:pPr algn="ctr"/>
+            <a:endParaRPr/>
           </a:p>
         </p:txBody>
       </p:sp>
@@ -20868,6 +21284,7 @@
           <a:lstStyle/>
           <a:p>
             <a:pPr algn="ctr"/>
+            <a:endParaRPr/>
           </a:p>
         </p:txBody>
       </p:sp>
@@ -20911,6 +21328,7 @@
           <a:lstStyle/>
           <a:p>
             <a:pPr algn="ctr"/>
+            <a:endParaRPr/>
           </a:p>
         </p:txBody>
       </p:sp>
@@ -20954,6 +21372,7 @@
           <a:lstStyle/>
           <a:p>
             <a:pPr algn="ctr"/>
+            <a:endParaRPr/>
           </a:p>
         </p:txBody>
       </p:sp>
@@ -20997,6 +21416,7 @@
           <a:lstStyle/>
           <a:p>
             <a:pPr algn="ctr"/>
+            <a:endParaRPr/>
           </a:p>
         </p:txBody>
       </p:sp>
@@ -21040,6 +21460,7 @@
           <a:lstStyle/>
           <a:p>
             <a:pPr algn="ctr"/>
+            <a:endParaRPr/>
           </a:p>
         </p:txBody>
       </p:sp>
@@ -21083,6 +21504,7 @@
           <a:lstStyle/>
           <a:p>
             <a:pPr algn="ctr"/>
+            <a:endParaRPr/>
           </a:p>
         </p:txBody>
       </p:sp>
@@ -21126,6 +21548,7 @@
           <a:lstStyle/>
           <a:p>
             <a:pPr algn="ctr"/>
+            <a:endParaRPr/>
           </a:p>
         </p:txBody>
       </p:sp>
@@ -21169,6 +21592,7 @@
           <a:lstStyle/>
           <a:p>
             <a:pPr algn="ctr"/>
+            <a:endParaRPr/>
           </a:p>
         </p:txBody>
       </p:sp>
@@ -21212,6 +21636,7 @@
           <a:lstStyle/>
           <a:p>
             <a:pPr algn="ctr"/>
+            <a:endParaRPr/>
           </a:p>
         </p:txBody>
       </p:sp>
@@ -21255,6 +21680,7 @@
           <a:lstStyle/>
           <a:p>
             <a:pPr algn="ctr"/>
+            <a:endParaRPr/>
           </a:p>
         </p:txBody>
       </p:sp>
@@ -21298,6 +21724,7 @@
           <a:lstStyle/>
           <a:p>
             <a:pPr algn="ctr"/>
+            <a:endParaRPr/>
           </a:p>
         </p:txBody>
       </p:sp>
@@ -21341,6 +21768,7 @@
           <a:lstStyle/>
           <a:p>
             <a:pPr algn="ctr"/>
+            <a:endParaRPr/>
           </a:p>
         </p:txBody>
       </p:sp>
@@ -21384,6 +21812,7 @@
           <a:lstStyle/>
           <a:p>
             <a:pPr algn="ctr"/>
+            <a:endParaRPr/>
           </a:p>
         </p:txBody>
       </p:sp>
@@ -21427,6 +21856,7 @@
           <a:lstStyle/>
           <a:p>
             <a:pPr algn="ctr"/>
+            <a:endParaRPr/>
           </a:p>
         </p:txBody>
       </p:sp>
@@ -21470,6 +21900,7 @@
           <a:lstStyle/>
           <a:p>
             <a:pPr algn="ctr"/>
+            <a:endParaRPr/>
           </a:p>
         </p:txBody>
       </p:sp>
@@ -21513,6 +21944,7 @@
           <a:lstStyle/>
           <a:p>
             <a:pPr algn="ctr"/>
+            <a:endParaRPr/>
           </a:p>
         </p:txBody>
       </p:sp>
@@ -21556,6 +21988,7 @@
           <a:lstStyle/>
           <a:p>
             <a:pPr algn="ctr"/>
+            <a:endParaRPr/>
           </a:p>
         </p:txBody>
       </p:sp>
@@ -21599,6 +22032,7 @@
           <a:lstStyle/>
           <a:p>
             <a:pPr algn="ctr"/>
+            <a:endParaRPr/>
           </a:p>
         </p:txBody>
       </p:sp>
@@ -21642,6 +22076,7 @@
           <a:lstStyle/>
           <a:p>
             <a:pPr algn="ctr"/>
+            <a:endParaRPr/>
           </a:p>
         </p:txBody>
       </p:sp>
@@ -21685,6 +22120,7 @@
           <a:lstStyle/>
           <a:p>
             <a:pPr algn="ctr"/>
+            <a:endParaRPr/>
           </a:p>
         </p:txBody>
       </p:sp>
@@ -21728,6 +22164,7 @@
           <a:lstStyle/>
           <a:p>
             <a:pPr algn="ctr"/>
+            <a:endParaRPr/>
           </a:p>
         </p:txBody>
       </p:sp>
@@ -21771,6 +22208,7 @@
           <a:lstStyle/>
           <a:p>
             <a:pPr algn="ctr"/>
+            <a:endParaRPr/>
           </a:p>
         </p:txBody>
       </p:sp>
@@ -21814,6 +22252,7 @@
           <a:lstStyle/>
           <a:p>
             <a:pPr algn="ctr"/>
+            <a:endParaRPr/>
           </a:p>
         </p:txBody>
       </p:sp>
@@ -21857,6 +22296,7 @@
           <a:lstStyle/>
           <a:p>
             <a:pPr algn="ctr"/>
+            <a:endParaRPr/>
           </a:p>
         </p:txBody>
       </p:sp>
@@ -21900,6 +22340,7 @@
           <a:lstStyle/>
           <a:p>
             <a:pPr algn="ctr"/>
+            <a:endParaRPr/>
           </a:p>
         </p:txBody>
       </p:sp>
@@ -21943,6 +22384,7 @@
           <a:lstStyle/>
           <a:p>
             <a:pPr algn="ctr"/>
+            <a:endParaRPr/>
           </a:p>
         </p:txBody>
       </p:sp>
@@ -21986,6 +22428,7 @@
           <a:lstStyle/>
           <a:p>
             <a:pPr algn="ctr"/>
+            <a:endParaRPr/>
           </a:p>
         </p:txBody>
       </p:sp>
@@ -22029,6 +22472,7 @@
           <a:lstStyle/>
           <a:p>
             <a:pPr algn="ctr"/>
+            <a:endParaRPr/>
           </a:p>
         </p:txBody>
       </p:sp>
@@ -22072,6 +22516,7 @@
           <a:lstStyle/>
           <a:p>
             <a:pPr algn="ctr"/>
+            <a:endParaRPr/>
           </a:p>
         </p:txBody>
       </p:sp>
@@ -22115,6 +22560,7 @@
           <a:lstStyle/>
           <a:p>
             <a:pPr algn="ctr"/>
+            <a:endParaRPr/>
           </a:p>
         </p:txBody>
       </p:sp>
@@ -22158,6 +22604,7 @@
           <a:lstStyle/>
           <a:p>
             <a:pPr algn="ctr"/>
+            <a:endParaRPr/>
           </a:p>
         </p:txBody>
       </p:sp>
@@ -22201,6 +22648,7 @@
           <a:lstStyle/>
           <a:p>
             <a:pPr algn="ctr"/>
+            <a:endParaRPr/>
           </a:p>
         </p:txBody>
       </p:sp>
@@ -22244,6 +22692,7 @@
           <a:lstStyle/>
           <a:p>
             <a:pPr algn="ctr"/>
+            <a:endParaRPr/>
           </a:p>
         </p:txBody>
       </p:sp>
@@ -22287,6 +22736,7 @@
           <a:lstStyle/>
           <a:p>
             <a:pPr algn="ctr"/>
+            <a:endParaRPr/>
           </a:p>
         </p:txBody>
       </p:sp>
@@ -22330,6 +22780,7 @@
           <a:lstStyle/>
           <a:p>
             <a:pPr algn="ctr"/>
+            <a:endParaRPr/>
           </a:p>
         </p:txBody>
       </p:sp>
@@ -22373,6 +22824,7 @@
           <a:lstStyle/>
           <a:p>
             <a:pPr algn="ctr"/>
+            <a:endParaRPr/>
           </a:p>
         </p:txBody>
       </p:sp>
@@ -22416,6 +22868,7 @@
           <a:lstStyle/>
           <a:p>
             <a:pPr algn="ctr"/>
+            <a:endParaRPr/>
           </a:p>
         </p:txBody>
       </p:sp>
@@ -22459,6 +22912,7 @@
           <a:lstStyle/>
           <a:p>
             <a:pPr algn="ctr"/>
+            <a:endParaRPr/>
           </a:p>
         </p:txBody>
       </p:sp>
@@ -22502,6 +22956,7 @@
           <a:lstStyle/>
           <a:p>
             <a:pPr algn="ctr"/>
+            <a:endParaRPr/>
           </a:p>
         </p:txBody>
       </p:sp>
@@ -22545,6 +23000,7 @@
           <a:lstStyle/>
           <a:p>
             <a:pPr algn="ctr"/>
+            <a:endParaRPr/>
           </a:p>
         </p:txBody>
       </p:sp>
@@ -22588,6 +23044,7 @@
           <a:lstStyle/>
           <a:p>
             <a:pPr algn="ctr"/>
+            <a:endParaRPr/>
           </a:p>
         </p:txBody>
       </p:sp>
@@ -22631,6 +23088,7 @@
           <a:lstStyle/>
           <a:p>
             <a:pPr algn="ctr"/>
+            <a:endParaRPr/>
           </a:p>
         </p:txBody>
       </p:sp>
@@ -22674,6 +23132,7 @@
           <a:lstStyle/>
           <a:p>
             <a:pPr algn="ctr"/>
+            <a:endParaRPr/>
           </a:p>
         </p:txBody>
       </p:sp>
@@ -22717,6 +23176,7 @@
           <a:lstStyle/>
           <a:p>
             <a:pPr algn="ctr"/>
+            <a:endParaRPr/>
           </a:p>
         </p:txBody>
       </p:sp>
@@ -22760,6 +23220,7 @@
           <a:lstStyle/>
           <a:p>
             <a:pPr algn="ctr"/>
+            <a:endParaRPr/>
           </a:p>
         </p:txBody>
       </p:sp>
@@ -22803,6 +23264,7 @@
           <a:lstStyle/>
           <a:p>
             <a:pPr algn="ctr"/>
+            <a:endParaRPr/>
           </a:p>
         </p:txBody>
       </p:sp>
@@ -22846,6 +23308,7 @@
           <a:lstStyle/>
           <a:p>
             <a:pPr algn="ctr"/>
+            <a:endParaRPr/>
           </a:p>
         </p:txBody>
       </p:sp>
@@ -22889,6 +23352,7 @@
           <a:lstStyle/>
           <a:p>
             <a:pPr algn="ctr"/>
+            <a:endParaRPr/>
           </a:p>
         </p:txBody>
       </p:sp>
@@ -22932,6 +23396,7 @@
           <a:lstStyle/>
           <a:p>
             <a:pPr algn="ctr"/>
+            <a:endParaRPr/>
           </a:p>
         </p:txBody>
       </p:sp>
@@ -22975,6 +23440,7 @@
           <a:lstStyle/>
           <a:p>
             <a:pPr algn="ctr"/>
+            <a:endParaRPr/>
           </a:p>
         </p:txBody>
       </p:sp>
@@ -23018,6 +23484,7 @@
           <a:lstStyle/>
           <a:p>
             <a:pPr algn="ctr"/>
+            <a:endParaRPr/>
           </a:p>
         </p:txBody>
       </p:sp>
@@ -23061,6 +23528,7 @@
           <a:lstStyle/>
           <a:p>
             <a:pPr algn="ctr"/>
+            <a:endParaRPr/>
           </a:p>
         </p:txBody>
       </p:sp>
@@ -23104,6 +23572,7 @@
           <a:lstStyle/>
           <a:p>
             <a:pPr algn="ctr"/>
+            <a:endParaRPr/>
           </a:p>
         </p:txBody>
       </p:sp>
@@ -23147,6 +23616,7 @@
           <a:lstStyle/>
           <a:p>
             <a:pPr algn="ctr"/>
+            <a:endParaRPr/>
           </a:p>
         </p:txBody>
       </p:sp>
@@ -23190,6 +23660,7 @@
           <a:lstStyle/>
           <a:p>
             <a:pPr algn="ctr"/>
+            <a:endParaRPr/>
           </a:p>
         </p:txBody>
       </p:sp>
@@ -23233,6 +23704,7 @@
           <a:lstStyle/>
           <a:p>
             <a:pPr algn="ctr"/>
+            <a:endParaRPr/>
           </a:p>
         </p:txBody>
       </p:sp>
@@ -23278,6 +23750,7 @@
           <a:lstStyle/>
           <a:p>
             <a:pPr algn="ctr"/>
+            <a:endParaRPr/>
           </a:p>
         </p:txBody>
       </p:sp>
@@ -23321,6 +23794,7 @@
           <a:lstStyle/>
           <a:p>
             <a:pPr algn="ctr"/>
+            <a:endParaRPr/>
           </a:p>
         </p:txBody>
       </p:sp>
@@ -23434,6 +23908,7 @@
           <a:lstStyle/>
           <a:p>
             <a:pPr algn="ctr"/>
+            <a:endParaRPr/>
           </a:p>
         </p:txBody>
       </p:sp>
@@ -23477,6 +23952,7 @@
           <a:lstStyle/>
           <a:p>
             <a:pPr algn="ctr"/>
+            <a:endParaRPr/>
           </a:p>
         </p:txBody>
       </p:sp>
@@ -23590,6 +24066,7 @@
           <a:lstStyle/>
           <a:p>
             <a:pPr algn="ctr"/>
+            <a:endParaRPr/>
           </a:p>
         </p:txBody>
       </p:sp>
@@ -23602,7 +24079,7 @@
         <p:spPr>
           <a:xfrm>
             <a:off x="2743200" y="3465575"/>
-            <a:ext cx="1097280" cy="347472"/>
+            <a:ext cx="1097280" cy="261610"/>
           </a:xfrm>
           <a:prstGeom prst="rect">
             <a:avLst/>
@@ -23617,14 +24094,20 @@
           <a:p>
             <a:pPr algn="ctr"/>
             <a:r>
-              <a:rPr sz="1100" b="1" i="0">
+              <a:rPr lang="en-US" sz="1100" b="1" i="0" dirty="0">
                 <a:solidFill>
                   <a:srgbClr val="FFFFFF"/>
                 </a:solidFill>
                 <a:latin typeface="Calibri"/>
               </a:rPr>
-              <a:t>GitHub</a:t>
+              <a:t>Email</a:t>
             </a:r>
+            <a:endParaRPr sz="1100" b="1" i="0" dirty="0">
+              <a:solidFill>
+                <a:srgbClr val="FFFFFF"/>
+              </a:solidFill>
+              <a:latin typeface="Calibri"/>
+            </a:endParaRPr>
           </a:p>
         </p:txBody>
       </p:sp>
@@ -23637,7 +24120,7 @@
         <p:spPr>
           <a:xfrm>
             <a:off x="3977639" y="3483863"/>
-            <a:ext cx="5486400" cy="347472"/>
+            <a:ext cx="5486400" cy="276999"/>
           </a:xfrm>
           <a:prstGeom prst="rect">
             <a:avLst/>
@@ -23652,14 +24135,20 @@
           <a:p>
             <a:pPr algn="l"/>
             <a:r>
-              <a:rPr sz="1200" b="0" i="0">
+              <a:rPr lang="en-US" sz="1200" dirty="0">
                 <a:solidFill>
                   <a:srgbClr val="06B6D4"/>
                 </a:solidFill>
                 <a:latin typeface="Consolas"/>
               </a:rPr>
-              <a:t>github.com/Luckyparihar11</a:t>
+              <a:t>Lucky.Parihar@avispl.com</a:t>
             </a:r>
+            <a:endParaRPr sz="1200" b="0" i="0" dirty="0">
+              <a:solidFill>
+                <a:srgbClr val="06B6D4"/>
+              </a:solidFill>
+              <a:latin typeface="Consolas"/>
+            </a:endParaRPr>
           </a:p>
         </p:txBody>
       </p:sp>
@@ -23703,6 +24192,7 @@
           <a:lstStyle/>
           <a:p>
             <a:pPr algn="ctr"/>
+            <a:endParaRPr/>
           </a:p>
         </p:txBody>
       </p:sp>
@@ -23772,41 +24262,6 @@
                 <a:latin typeface="Consolas"/>
               </a:rPr>
               <a:t>linkedin.com/in/lucky-parihar-b90425208</a:t>
-            </a:r>
-          </a:p>
-        </p:txBody>
-      </p:sp>
-      <p:sp>
-        <p:nvSpPr>
-          <p:cNvPr id="284" name="TextBox 283"/>
-          <p:cNvSpPr txBox="1"/>
-          <p:nvPr/>
-        </p:nvSpPr>
-        <p:spPr>
-          <a:xfrm>
-            <a:off x="1828800" y="5074920"/>
-            <a:ext cx="8686800" cy="411480"/>
-          </a:xfrm>
-          <a:prstGeom prst="rect">
-            <a:avLst/>
-          </a:prstGeom>
-          <a:noFill/>
-        </p:spPr>
-        <p:txBody>
-          <a:bodyPr wrap="square">
-            <a:spAutoFit/>
-          </a:bodyPr>
-          <a:lstStyle/>
-          <a:p>
-            <a:pPr algn="ctr"/>
-            <a:r>
-              <a:rPr sz="1100" b="0" i="1">
-                <a:solidFill>
-                  <a:srgbClr val="64748B"/>
-                </a:solidFill>
-                <a:latin typeface="Calibri"/>
-              </a:rPr>
-              <a:t>Open an issue on GitHub or drop a message on LinkedIn — responses within 24 hours.</a:t>
             </a:r>
           </a:p>
         </p:txBody>

</xml_diff>